<commit_message>
Color Pkr with lock tool
</commit_message>
<xml_diff>
--- a/ColorPkr/assetSources/ColorPkr-Icons.pptx
+++ b/ColorPkr/assetSources/ColorPkr-Icons.pptx
@@ -264,7 +264,7 @@
           <a:p>
             <a:fld id="{127E456F-8AE8-4014-B338-718F1CA4F223}" type="datetimeFigureOut">
               <a:rPr lang="fr-CA" smtClean="0"/>
-              <a:t>2026-02-17</a:t>
+              <a:t>2026-02-20</a:t>
             </a:fld>
             <a:endParaRPr lang="fr-CA"/>
           </a:p>
@@ -464,7 +464,7 @@
           <a:p>
             <a:fld id="{127E456F-8AE8-4014-B338-718F1CA4F223}" type="datetimeFigureOut">
               <a:rPr lang="fr-CA" smtClean="0"/>
-              <a:t>2026-02-17</a:t>
+              <a:t>2026-02-20</a:t>
             </a:fld>
             <a:endParaRPr lang="fr-CA"/>
           </a:p>
@@ -674,7 +674,7 @@
           <a:p>
             <a:fld id="{127E456F-8AE8-4014-B338-718F1CA4F223}" type="datetimeFigureOut">
               <a:rPr lang="fr-CA" smtClean="0"/>
-              <a:t>2026-02-17</a:t>
+              <a:t>2026-02-20</a:t>
             </a:fld>
             <a:endParaRPr lang="fr-CA"/>
           </a:p>
@@ -874,7 +874,7 @@
           <a:p>
             <a:fld id="{127E456F-8AE8-4014-B338-718F1CA4F223}" type="datetimeFigureOut">
               <a:rPr lang="fr-CA" smtClean="0"/>
-              <a:t>2026-02-17</a:t>
+              <a:t>2026-02-20</a:t>
             </a:fld>
             <a:endParaRPr lang="fr-CA"/>
           </a:p>
@@ -1150,7 +1150,7 @@
           <a:p>
             <a:fld id="{127E456F-8AE8-4014-B338-718F1CA4F223}" type="datetimeFigureOut">
               <a:rPr lang="fr-CA" smtClean="0"/>
-              <a:t>2026-02-17</a:t>
+              <a:t>2026-02-20</a:t>
             </a:fld>
             <a:endParaRPr lang="fr-CA"/>
           </a:p>
@@ -1418,7 +1418,7 @@
           <a:p>
             <a:fld id="{127E456F-8AE8-4014-B338-718F1CA4F223}" type="datetimeFigureOut">
               <a:rPr lang="fr-CA" smtClean="0"/>
-              <a:t>2026-02-17</a:t>
+              <a:t>2026-02-20</a:t>
             </a:fld>
             <a:endParaRPr lang="fr-CA"/>
           </a:p>
@@ -1833,7 +1833,7 @@
           <a:p>
             <a:fld id="{127E456F-8AE8-4014-B338-718F1CA4F223}" type="datetimeFigureOut">
               <a:rPr lang="fr-CA" smtClean="0"/>
-              <a:t>2026-02-17</a:t>
+              <a:t>2026-02-20</a:t>
             </a:fld>
             <a:endParaRPr lang="fr-CA"/>
           </a:p>
@@ -1975,7 +1975,7 @@
           <a:p>
             <a:fld id="{127E456F-8AE8-4014-B338-718F1CA4F223}" type="datetimeFigureOut">
               <a:rPr lang="fr-CA" smtClean="0"/>
-              <a:t>2026-02-17</a:t>
+              <a:t>2026-02-20</a:t>
             </a:fld>
             <a:endParaRPr lang="fr-CA"/>
           </a:p>
@@ -2088,7 +2088,7 @@
           <a:p>
             <a:fld id="{127E456F-8AE8-4014-B338-718F1CA4F223}" type="datetimeFigureOut">
               <a:rPr lang="fr-CA" smtClean="0"/>
-              <a:t>2026-02-17</a:t>
+              <a:t>2026-02-20</a:t>
             </a:fld>
             <a:endParaRPr lang="fr-CA"/>
           </a:p>
@@ -2401,7 +2401,7 @@
           <a:p>
             <a:fld id="{127E456F-8AE8-4014-B338-718F1CA4F223}" type="datetimeFigureOut">
               <a:rPr lang="fr-CA" smtClean="0"/>
-              <a:t>2026-02-17</a:t>
+              <a:t>2026-02-20</a:t>
             </a:fld>
             <a:endParaRPr lang="fr-CA"/>
           </a:p>
@@ -2690,7 +2690,7 @@
           <a:p>
             <a:fld id="{127E456F-8AE8-4014-B338-718F1CA4F223}" type="datetimeFigureOut">
               <a:rPr lang="fr-CA" smtClean="0"/>
-              <a:t>2026-02-17</a:t>
+              <a:t>2026-02-20</a:t>
             </a:fld>
             <a:endParaRPr lang="fr-CA"/>
           </a:p>
@@ -2933,7 +2933,7 @@
           <a:p>
             <a:fld id="{127E456F-8AE8-4014-B338-718F1CA4F223}" type="datetimeFigureOut">
               <a:rPr lang="fr-CA" smtClean="0"/>
-              <a:t>2026-02-17</a:t>
+              <a:t>2026-02-20</a:t>
             </a:fld>
             <a:endParaRPr lang="fr-CA"/>
           </a:p>
@@ -8758,6 +8758,1582 @@
           </a:p>
         </p:txBody>
       </p:sp>
+      <p:grpSp>
+        <p:nvGrpSpPr>
+          <p:cNvPr id="8" name="Group 7">
+            <a:extLst>
+              <a:ext uri="{FF2B5EF4-FFF2-40B4-BE49-F238E27FC236}">
+                <a16:creationId xmlns:a16="http://schemas.microsoft.com/office/drawing/2014/main" id="{CEAC5E29-B711-075E-A946-AB37F83D9E21}"/>
+              </a:ext>
+            </a:extLst>
+          </p:cNvPr>
+          <p:cNvGrpSpPr>
+            <a:grpSpLocks noChangeAspect="1"/>
+          </p:cNvGrpSpPr>
+          <p:nvPr/>
+        </p:nvGrpSpPr>
+        <p:grpSpPr>
+          <a:xfrm>
+            <a:off x="3147868" y="4876662"/>
+            <a:ext cx="769929" cy="720000"/>
+            <a:chOff x="4382930" y="1044131"/>
+            <a:chExt cx="4485670" cy="4194779"/>
+          </a:xfrm>
+        </p:grpSpPr>
+        <p:sp>
+          <p:nvSpPr>
+            <p:cNvPr id="10" name="Oval 9">
+              <a:extLst>
+                <a:ext uri="{FF2B5EF4-FFF2-40B4-BE49-F238E27FC236}">
+                  <a16:creationId xmlns:a16="http://schemas.microsoft.com/office/drawing/2014/main" id="{A151374D-9141-0827-6DEA-52BE923A1B36}"/>
+                </a:ext>
+              </a:extLst>
+            </p:cNvPr>
+            <p:cNvSpPr/>
+            <p:nvPr/>
+          </p:nvSpPr>
+          <p:spPr>
+            <a:xfrm>
+              <a:off x="5372454" y="3449130"/>
+              <a:ext cx="1238865" cy="1447335"/>
+            </a:xfrm>
+            <a:prstGeom prst="ellipse">
+              <a:avLst/>
+            </a:prstGeom>
+            <a:solidFill>
+              <a:srgbClr val="333333"/>
+            </a:solidFill>
+          </p:spPr>
+          <p:style>
+            <a:lnRef idx="2">
+              <a:schemeClr val="accent1">
+                <a:shade val="15000"/>
+              </a:schemeClr>
+            </a:lnRef>
+            <a:fillRef idx="1">
+              <a:schemeClr val="accent1"/>
+            </a:fillRef>
+            <a:effectRef idx="0">
+              <a:schemeClr val="accent1"/>
+            </a:effectRef>
+            <a:fontRef idx="minor">
+              <a:schemeClr val="lt1"/>
+            </a:fontRef>
+          </p:style>
+          <p:txBody>
+            <a:bodyPr rtlCol="0" anchor="ctr"/>
+            <a:lstStyle/>
+            <a:p>
+              <a:pPr algn="ctr"/>
+              <a:endParaRPr lang="fr-CA"/>
+            </a:p>
+          </p:txBody>
+        </p:sp>
+        <p:sp>
+          <p:nvSpPr>
+            <p:cNvPr id="11" name="Graphic 14" descr="Lock with solid fill">
+              <a:extLst>
+                <a:ext uri="{FF2B5EF4-FFF2-40B4-BE49-F238E27FC236}">
+                  <a16:creationId xmlns:a16="http://schemas.microsoft.com/office/drawing/2014/main" id="{17BF92F5-FE88-F47E-999D-D92035BCF8F4}"/>
+                </a:ext>
+              </a:extLst>
+            </p:cNvPr>
+            <p:cNvSpPr/>
+            <p:nvPr/>
+          </p:nvSpPr>
+          <p:spPr>
+            <a:xfrm>
+              <a:off x="4382930" y="1044131"/>
+              <a:ext cx="3217913" cy="4194779"/>
+            </a:xfrm>
+            <a:custGeom>
+              <a:avLst/>
+              <a:gdLst>
+                <a:gd name="csX0" fmla="*/ 285750 w 533400"/>
+                <a:gd name="csY0" fmla="*/ 549593 h 695325"/>
+                <a:gd name="csX1" fmla="*/ 285750 w 533400"/>
+                <a:gd name="csY1" fmla="*/ 600075 h 695325"/>
+                <a:gd name="csX2" fmla="*/ 247650 w 533400"/>
+                <a:gd name="csY2" fmla="*/ 600075 h 695325"/>
+                <a:gd name="csX3" fmla="*/ 247650 w 533400"/>
+                <a:gd name="csY3" fmla="*/ 549593 h 695325"/>
+                <a:gd name="csX4" fmla="*/ 209550 w 533400"/>
+                <a:gd name="csY4" fmla="*/ 495300 h 695325"/>
+                <a:gd name="csX5" fmla="*/ 266700 w 533400"/>
+                <a:gd name="csY5" fmla="*/ 438150 h 695325"/>
+                <a:gd name="csX6" fmla="*/ 323850 w 533400"/>
+                <a:gd name="csY6" fmla="*/ 495300 h 695325"/>
+                <a:gd name="csX7" fmla="*/ 285750 w 533400"/>
+                <a:gd name="csY7" fmla="*/ 549593 h 695325"/>
+                <a:gd name="csX8" fmla="*/ 123825 w 533400"/>
+                <a:gd name="csY8" fmla="*/ 200025 h 695325"/>
+                <a:gd name="csX9" fmla="*/ 266700 w 533400"/>
+                <a:gd name="csY9" fmla="*/ 57150 h 695325"/>
+                <a:gd name="csX10" fmla="*/ 409575 w 533400"/>
+                <a:gd name="csY10" fmla="*/ 200025 h 695325"/>
+                <a:gd name="csX11" fmla="*/ 409575 w 533400"/>
+                <a:gd name="csY11" fmla="*/ 305753 h 695325"/>
+                <a:gd name="csX12" fmla="*/ 266700 w 533400"/>
+                <a:gd name="csY12" fmla="*/ 295275 h 695325"/>
+                <a:gd name="csX13" fmla="*/ 123825 w 533400"/>
+                <a:gd name="csY13" fmla="*/ 305753 h 695325"/>
+                <a:gd name="csX14" fmla="*/ 123825 w 533400"/>
+                <a:gd name="csY14" fmla="*/ 200025 h 695325"/>
+                <a:gd name="csX15" fmla="*/ 466725 w 533400"/>
+                <a:gd name="csY15" fmla="*/ 309563 h 695325"/>
+                <a:gd name="csX16" fmla="*/ 466725 w 533400"/>
+                <a:gd name="csY16" fmla="*/ 200025 h 695325"/>
+                <a:gd name="csX17" fmla="*/ 266700 w 533400"/>
+                <a:gd name="csY17" fmla="*/ 0 h 695325"/>
+                <a:gd name="csX18" fmla="*/ 66675 w 533400"/>
+                <a:gd name="csY18" fmla="*/ 200025 h 695325"/>
+                <a:gd name="csX19" fmla="*/ 66675 w 533400"/>
+                <a:gd name="csY19" fmla="*/ 309563 h 695325"/>
+                <a:gd name="csX20" fmla="*/ 0 w 533400"/>
+                <a:gd name="csY20" fmla="*/ 314325 h 695325"/>
+                <a:gd name="csX21" fmla="*/ 0 w 533400"/>
+                <a:gd name="csY21" fmla="*/ 676275 h 695325"/>
+                <a:gd name="csX22" fmla="*/ 266700 w 533400"/>
+                <a:gd name="csY22" fmla="*/ 695325 h 695325"/>
+                <a:gd name="csX23" fmla="*/ 533400 w 533400"/>
+                <a:gd name="csY23" fmla="*/ 676275 h 695325"/>
+                <a:gd name="csX24" fmla="*/ 533400 w 533400"/>
+                <a:gd name="csY24" fmla="*/ 314325 h 695325"/>
+                <a:gd name="csX25" fmla="*/ 466725 w 533400"/>
+                <a:gd name="csY25" fmla="*/ 309563 h 695325"/>
+              </a:gdLst>
+              <a:ahLst/>
+              <a:cxnLst>
+                <a:cxn ang="0">
+                  <a:pos x="csX0" y="csY0"/>
+                </a:cxn>
+                <a:cxn ang="0">
+                  <a:pos x="csX1" y="csY1"/>
+                </a:cxn>
+                <a:cxn ang="0">
+                  <a:pos x="csX2" y="csY2"/>
+                </a:cxn>
+                <a:cxn ang="0">
+                  <a:pos x="csX3" y="csY3"/>
+                </a:cxn>
+                <a:cxn ang="0">
+                  <a:pos x="csX4" y="csY4"/>
+                </a:cxn>
+                <a:cxn ang="0">
+                  <a:pos x="csX5" y="csY5"/>
+                </a:cxn>
+                <a:cxn ang="0">
+                  <a:pos x="csX6" y="csY6"/>
+                </a:cxn>
+                <a:cxn ang="0">
+                  <a:pos x="csX7" y="csY7"/>
+                </a:cxn>
+                <a:cxn ang="0">
+                  <a:pos x="csX8" y="csY8"/>
+                </a:cxn>
+                <a:cxn ang="0">
+                  <a:pos x="csX9" y="csY9"/>
+                </a:cxn>
+                <a:cxn ang="0">
+                  <a:pos x="csX10" y="csY10"/>
+                </a:cxn>
+                <a:cxn ang="0">
+                  <a:pos x="csX11" y="csY11"/>
+                </a:cxn>
+                <a:cxn ang="0">
+                  <a:pos x="csX12" y="csY12"/>
+                </a:cxn>
+                <a:cxn ang="0">
+                  <a:pos x="csX13" y="csY13"/>
+                </a:cxn>
+                <a:cxn ang="0">
+                  <a:pos x="csX14" y="csY14"/>
+                </a:cxn>
+                <a:cxn ang="0">
+                  <a:pos x="csX15" y="csY15"/>
+                </a:cxn>
+                <a:cxn ang="0">
+                  <a:pos x="csX16" y="csY16"/>
+                </a:cxn>
+                <a:cxn ang="0">
+                  <a:pos x="csX17" y="csY17"/>
+                </a:cxn>
+                <a:cxn ang="0">
+                  <a:pos x="csX18" y="csY18"/>
+                </a:cxn>
+                <a:cxn ang="0">
+                  <a:pos x="csX19" y="csY19"/>
+                </a:cxn>
+                <a:cxn ang="0">
+                  <a:pos x="csX20" y="csY20"/>
+                </a:cxn>
+                <a:cxn ang="0">
+                  <a:pos x="csX21" y="csY21"/>
+                </a:cxn>
+                <a:cxn ang="0">
+                  <a:pos x="csX22" y="csY22"/>
+                </a:cxn>
+                <a:cxn ang="0">
+                  <a:pos x="csX23" y="csY23"/>
+                </a:cxn>
+                <a:cxn ang="0">
+                  <a:pos x="csX24" y="csY24"/>
+                </a:cxn>
+                <a:cxn ang="0">
+                  <a:pos x="csX25" y="csY25"/>
+                </a:cxn>
+              </a:cxnLst>
+              <a:rect l="l" t="t" r="r" b="b"/>
+              <a:pathLst>
+                <a:path w="533400" h="695325">
+                  <a:moveTo>
+                    <a:pt x="285750" y="549593"/>
+                  </a:moveTo>
+                  <a:lnTo>
+                    <a:pt x="285750" y="600075"/>
+                  </a:lnTo>
+                  <a:lnTo>
+                    <a:pt x="247650" y="600075"/>
+                  </a:lnTo>
+                  <a:lnTo>
+                    <a:pt x="247650" y="549593"/>
+                  </a:lnTo>
+                  <a:cubicBezTo>
+                    <a:pt x="225743" y="541973"/>
+                    <a:pt x="209550" y="521017"/>
+                    <a:pt x="209550" y="495300"/>
+                  </a:cubicBezTo>
+                  <a:cubicBezTo>
+                    <a:pt x="209550" y="463868"/>
+                    <a:pt x="235268" y="438150"/>
+                    <a:pt x="266700" y="438150"/>
+                  </a:cubicBezTo>
+                  <a:cubicBezTo>
+                    <a:pt x="298133" y="438150"/>
+                    <a:pt x="323850" y="463868"/>
+                    <a:pt x="323850" y="495300"/>
+                  </a:cubicBezTo>
+                  <a:cubicBezTo>
+                    <a:pt x="323850" y="520065"/>
+                    <a:pt x="307658" y="541020"/>
+                    <a:pt x="285750" y="549593"/>
+                  </a:cubicBezTo>
+                  <a:close/>
+                  <a:moveTo>
+                    <a:pt x="123825" y="200025"/>
+                  </a:moveTo>
+                  <a:cubicBezTo>
+                    <a:pt x="123825" y="120968"/>
+                    <a:pt x="187643" y="57150"/>
+                    <a:pt x="266700" y="57150"/>
+                  </a:cubicBezTo>
+                  <a:cubicBezTo>
+                    <a:pt x="345758" y="57150"/>
+                    <a:pt x="409575" y="120968"/>
+                    <a:pt x="409575" y="200025"/>
+                  </a:cubicBezTo>
+                  <a:lnTo>
+                    <a:pt x="409575" y="305753"/>
+                  </a:lnTo>
+                  <a:lnTo>
+                    <a:pt x="266700" y="295275"/>
+                  </a:lnTo>
+                  <a:lnTo>
+                    <a:pt x="123825" y="305753"/>
+                  </a:lnTo>
+                  <a:lnTo>
+                    <a:pt x="123825" y="200025"/>
+                  </a:lnTo>
+                  <a:close/>
+                  <a:moveTo>
+                    <a:pt x="466725" y="309563"/>
+                  </a:moveTo>
+                  <a:lnTo>
+                    <a:pt x="466725" y="200025"/>
+                  </a:lnTo>
+                  <a:cubicBezTo>
+                    <a:pt x="466725" y="89535"/>
+                    <a:pt x="377190" y="0"/>
+                    <a:pt x="266700" y="0"/>
+                  </a:cubicBezTo>
+                  <a:cubicBezTo>
+                    <a:pt x="156210" y="0"/>
+                    <a:pt x="66675" y="89535"/>
+                    <a:pt x="66675" y="200025"/>
+                  </a:cubicBezTo>
+                  <a:lnTo>
+                    <a:pt x="66675" y="309563"/>
+                  </a:lnTo>
+                  <a:lnTo>
+                    <a:pt x="0" y="314325"/>
+                  </a:lnTo>
+                  <a:lnTo>
+                    <a:pt x="0" y="676275"/>
+                  </a:lnTo>
+                  <a:lnTo>
+                    <a:pt x="266700" y="695325"/>
+                  </a:lnTo>
+                  <a:lnTo>
+                    <a:pt x="533400" y="676275"/>
+                  </a:lnTo>
+                  <a:lnTo>
+                    <a:pt x="533400" y="314325"/>
+                  </a:lnTo>
+                  <a:lnTo>
+                    <a:pt x="466725" y="309563"/>
+                  </a:lnTo>
+                  <a:close/>
+                </a:path>
+              </a:pathLst>
+            </a:custGeom>
+            <a:solidFill>
+              <a:srgbClr val="CCCCCC"/>
+            </a:solidFill>
+            <a:ln w="9525" cap="flat">
+              <a:noFill/>
+              <a:prstDash val="solid"/>
+              <a:miter/>
+            </a:ln>
+          </p:spPr>
+          <p:txBody>
+            <a:bodyPr/>
+            <a:lstStyle/>
+            <a:p>
+              <a:endParaRPr lang="fr-CA"/>
+            </a:p>
+          </p:txBody>
+        </p:sp>
+        <p:sp>
+          <p:nvSpPr>
+            <p:cNvPr id="12" name="Rectangle 11">
+              <a:extLst>
+                <a:ext uri="{FF2B5EF4-FFF2-40B4-BE49-F238E27FC236}">
+                  <a16:creationId xmlns:a16="http://schemas.microsoft.com/office/drawing/2014/main" id="{F034F56A-ABDF-A7AE-586B-36EBD475EB02}"/>
+                </a:ext>
+              </a:extLst>
+            </p:cNvPr>
+            <p:cNvSpPr/>
+            <p:nvPr/>
+          </p:nvSpPr>
+          <p:spPr>
+            <a:xfrm>
+              <a:off x="4738785" y="2982771"/>
+              <a:ext cx="2506202" cy="36000"/>
+            </a:xfrm>
+            <a:prstGeom prst="rect">
+              <a:avLst/>
+            </a:prstGeom>
+            <a:solidFill>
+              <a:srgbClr val="999999"/>
+            </a:solidFill>
+            <a:ln>
+              <a:noFill/>
+            </a:ln>
+          </p:spPr>
+          <p:style>
+            <a:lnRef idx="2">
+              <a:schemeClr val="accent1">
+                <a:shade val="15000"/>
+              </a:schemeClr>
+            </a:lnRef>
+            <a:fillRef idx="1">
+              <a:schemeClr val="accent1"/>
+            </a:fillRef>
+            <a:effectRef idx="0">
+              <a:schemeClr val="accent1"/>
+            </a:effectRef>
+            <a:fontRef idx="minor">
+              <a:schemeClr val="lt1"/>
+            </a:fontRef>
+          </p:style>
+          <p:txBody>
+            <a:bodyPr rtlCol="0" anchor="ctr"/>
+            <a:lstStyle/>
+            <a:p>
+              <a:pPr algn="ctr"/>
+              <a:endParaRPr lang="fr-CA"/>
+            </a:p>
+          </p:txBody>
+        </p:sp>
+        <p:sp>
+          <p:nvSpPr>
+            <p:cNvPr id="16" name="Rectangle 15">
+              <a:extLst>
+                <a:ext uri="{FF2B5EF4-FFF2-40B4-BE49-F238E27FC236}">
+                  <a16:creationId xmlns:a16="http://schemas.microsoft.com/office/drawing/2014/main" id="{60A6AFB1-5458-854F-7E1B-C2E99A61C58D}"/>
+                </a:ext>
+              </a:extLst>
+            </p:cNvPr>
+            <p:cNvSpPr/>
+            <p:nvPr/>
+          </p:nvSpPr>
+          <p:spPr>
+            <a:xfrm>
+              <a:off x="4738785" y="3292458"/>
+              <a:ext cx="2506202" cy="36000"/>
+            </a:xfrm>
+            <a:prstGeom prst="rect">
+              <a:avLst/>
+            </a:prstGeom>
+            <a:solidFill>
+              <a:srgbClr val="999999"/>
+            </a:solidFill>
+            <a:ln>
+              <a:noFill/>
+            </a:ln>
+          </p:spPr>
+          <p:style>
+            <a:lnRef idx="2">
+              <a:schemeClr val="accent1">
+                <a:shade val="15000"/>
+              </a:schemeClr>
+            </a:lnRef>
+            <a:fillRef idx="1">
+              <a:schemeClr val="accent1"/>
+            </a:fillRef>
+            <a:effectRef idx="0">
+              <a:schemeClr val="accent1"/>
+            </a:effectRef>
+            <a:fontRef idx="minor">
+              <a:schemeClr val="lt1"/>
+            </a:fontRef>
+          </p:style>
+          <p:txBody>
+            <a:bodyPr rtlCol="0" anchor="ctr"/>
+            <a:lstStyle/>
+            <a:p>
+              <a:pPr algn="ctr"/>
+              <a:endParaRPr lang="fr-CA"/>
+            </a:p>
+          </p:txBody>
+        </p:sp>
+        <p:sp>
+          <p:nvSpPr>
+            <p:cNvPr id="17" name="Rectangle 16">
+              <a:extLst>
+                <a:ext uri="{FF2B5EF4-FFF2-40B4-BE49-F238E27FC236}">
+                  <a16:creationId xmlns:a16="http://schemas.microsoft.com/office/drawing/2014/main" id="{8BFB72CE-026E-741A-184B-1097CDE4A09D}"/>
+                </a:ext>
+              </a:extLst>
+            </p:cNvPr>
+            <p:cNvSpPr/>
+            <p:nvPr/>
+          </p:nvSpPr>
+          <p:spPr>
+            <a:xfrm>
+              <a:off x="4738785" y="4838668"/>
+              <a:ext cx="2506202" cy="36000"/>
+            </a:xfrm>
+            <a:prstGeom prst="rect">
+              <a:avLst/>
+            </a:prstGeom>
+            <a:solidFill>
+              <a:srgbClr val="999999"/>
+            </a:solidFill>
+            <a:ln>
+              <a:noFill/>
+            </a:ln>
+          </p:spPr>
+          <p:style>
+            <a:lnRef idx="2">
+              <a:schemeClr val="accent1">
+                <a:shade val="15000"/>
+              </a:schemeClr>
+            </a:lnRef>
+            <a:fillRef idx="1">
+              <a:schemeClr val="accent1"/>
+            </a:fillRef>
+            <a:effectRef idx="0">
+              <a:schemeClr val="accent1"/>
+            </a:effectRef>
+            <a:fontRef idx="minor">
+              <a:schemeClr val="lt1"/>
+            </a:fontRef>
+          </p:style>
+          <p:txBody>
+            <a:bodyPr rtlCol="0" anchor="ctr"/>
+            <a:lstStyle/>
+            <a:p>
+              <a:pPr algn="ctr"/>
+              <a:endParaRPr lang="fr-CA"/>
+            </a:p>
+          </p:txBody>
+        </p:sp>
+        <p:sp>
+          <p:nvSpPr>
+            <p:cNvPr id="18" name="Rectangle 17">
+              <a:extLst>
+                <a:ext uri="{FF2B5EF4-FFF2-40B4-BE49-F238E27FC236}">
+                  <a16:creationId xmlns:a16="http://schemas.microsoft.com/office/drawing/2014/main" id="{4A2B254F-6707-3A8C-9A6D-3CAC6D86CC79}"/>
+                </a:ext>
+              </a:extLst>
+            </p:cNvPr>
+            <p:cNvSpPr/>
+            <p:nvPr/>
+          </p:nvSpPr>
+          <p:spPr>
+            <a:xfrm>
+              <a:off x="4738785" y="3602146"/>
+              <a:ext cx="2506202" cy="36000"/>
+            </a:xfrm>
+            <a:prstGeom prst="rect">
+              <a:avLst/>
+            </a:prstGeom>
+            <a:solidFill>
+              <a:srgbClr val="999999"/>
+            </a:solidFill>
+            <a:ln>
+              <a:noFill/>
+            </a:ln>
+          </p:spPr>
+          <p:style>
+            <a:lnRef idx="2">
+              <a:schemeClr val="accent1">
+                <a:shade val="15000"/>
+              </a:schemeClr>
+            </a:lnRef>
+            <a:fillRef idx="1">
+              <a:schemeClr val="accent1"/>
+            </a:fillRef>
+            <a:effectRef idx="0">
+              <a:schemeClr val="accent1"/>
+            </a:effectRef>
+            <a:fontRef idx="minor">
+              <a:schemeClr val="lt1"/>
+            </a:fontRef>
+          </p:style>
+          <p:txBody>
+            <a:bodyPr rtlCol="0" anchor="ctr"/>
+            <a:lstStyle/>
+            <a:p>
+              <a:pPr algn="ctr"/>
+              <a:endParaRPr lang="fr-CA"/>
+            </a:p>
+          </p:txBody>
+        </p:sp>
+        <p:sp>
+          <p:nvSpPr>
+            <p:cNvPr id="38" name="Oval 37">
+              <a:extLst>
+                <a:ext uri="{FF2B5EF4-FFF2-40B4-BE49-F238E27FC236}">
+                  <a16:creationId xmlns:a16="http://schemas.microsoft.com/office/drawing/2014/main" id="{679F61AE-C427-F1BF-9AFA-53104C19784C}"/>
+                </a:ext>
+              </a:extLst>
+            </p:cNvPr>
+            <p:cNvSpPr/>
+            <p:nvPr/>
+          </p:nvSpPr>
+          <p:spPr>
+            <a:xfrm>
+              <a:off x="7968600" y="1794206"/>
+              <a:ext cx="900000" cy="900000"/>
+            </a:xfrm>
+            <a:prstGeom prst="ellipse">
+              <a:avLst/>
+            </a:prstGeom>
+            <a:solidFill>
+              <a:srgbClr val="CCCCCC"/>
+            </a:solidFill>
+            <a:ln>
+              <a:noFill/>
+            </a:ln>
+          </p:spPr>
+          <p:style>
+            <a:lnRef idx="2">
+              <a:schemeClr val="accent1">
+                <a:shade val="15000"/>
+              </a:schemeClr>
+            </a:lnRef>
+            <a:fillRef idx="1">
+              <a:schemeClr val="accent1"/>
+            </a:fillRef>
+            <a:effectRef idx="0">
+              <a:schemeClr val="accent1"/>
+            </a:effectRef>
+            <a:fontRef idx="minor">
+              <a:schemeClr val="lt1"/>
+            </a:fontRef>
+          </p:style>
+          <p:txBody>
+            <a:bodyPr rtlCol="0" anchor="ctr"/>
+            <a:lstStyle/>
+            <a:p>
+              <a:pPr algn="ctr"/>
+              <a:endParaRPr lang="fr-CA"/>
+            </a:p>
+          </p:txBody>
+        </p:sp>
+        <p:sp>
+          <p:nvSpPr>
+            <p:cNvPr id="57" name="Oval 56">
+              <a:extLst>
+                <a:ext uri="{FF2B5EF4-FFF2-40B4-BE49-F238E27FC236}">
+                  <a16:creationId xmlns:a16="http://schemas.microsoft.com/office/drawing/2014/main" id="{978F1734-6217-B8A2-92BC-95490DF76CEB}"/>
+                </a:ext>
+              </a:extLst>
+            </p:cNvPr>
+            <p:cNvSpPr/>
+            <p:nvPr/>
+          </p:nvSpPr>
+          <p:spPr>
+            <a:xfrm>
+              <a:off x="7968600" y="3057103"/>
+              <a:ext cx="900000" cy="900000"/>
+            </a:xfrm>
+            <a:prstGeom prst="ellipse">
+              <a:avLst/>
+            </a:prstGeom>
+            <a:solidFill>
+              <a:srgbClr val="999999"/>
+            </a:solidFill>
+            <a:ln>
+              <a:noFill/>
+            </a:ln>
+          </p:spPr>
+          <p:style>
+            <a:lnRef idx="2">
+              <a:schemeClr val="accent1">
+                <a:shade val="15000"/>
+              </a:schemeClr>
+            </a:lnRef>
+            <a:fillRef idx="1">
+              <a:schemeClr val="accent1"/>
+            </a:fillRef>
+            <a:effectRef idx="0">
+              <a:schemeClr val="accent1"/>
+            </a:effectRef>
+            <a:fontRef idx="minor">
+              <a:schemeClr val="lt1"/>
+            </a:fontRef>
+          </p:style>
+          <p:txBody>
+            <a:bodyPr rtlCol="0" anchor="ctr"/>
+            <a:lstStyle/>
+            <a:p>
+              <a:pPr algn="ctr"/>
+              <a:endParaRPr lang="fr-CA"/>
+            </a:p>
+          </p:txBody>
+        </p:sp>
+        <p:sp>
+          <p:nvSpPr>
+            <p:cNvPr id="58" name="Oval 57">
+              <a:extLst>
+                <a:ext uri="{FF2B5EF4-FFF2-40B4-BE49-F238E27FC236}">
+                  <a16:creationId xmlns:a16="http://schemas.microsoft.com/office/drawing/2014/main" id="{DCC56F4A-E6D6-FEB8-B4C6-B80EF6CC3CB1}"/>
+                </a:ext>
+              </a:extLst>
+            </p:cNvPr>
+            <p:cNvSpPr/>
+            <p:nvPr/>
+          </p:nvSpPr>
+          <p:spPr>
+            <a:xfrm>
+              <a:off x="7968600" y="4320000"/>
+              <a:ext cx="900000" cy="900000"/>
+            </a:xfrm>
+            <a:prstGeom prst="ellipse">
+              <a:avLst/>
+            </a:prstGeom>
+            <a:solidFill>
+              <a:srgbClr val="666666"/>
+            </a:solidFill>
+            <a:ln>
+              <a:noFill/>
+            </a:ln>
+          </p:spPr>
+          <p:style>
+            <a:lnRef idx="2">
+              <a:schemeClr val="accent1">
+                <a:shade val="15000"/>
+              </a:schemeClr>
+            </a:lnRef>
+            <a:fillRef idx="1">
+              <a:schemeClr val="accent1"/>
+            </a:fillRef>
+            <a:effectRef idx="0">
+              <a:schemeClr val="accent1"/>
+            </a:effectRef>
+            <a:fontRef idx="minor">
+              <a:schemeClr val="lt1"/>
+            </a:fontRef>
+          </p:style>
+          <p:txBody>
+            <a:bodyPr rtlCol="0" anchor="ctr"/>
+            <a:lstStyle/>
+            <a:p>
+              <a:pPr algn="ctr"/>
+              <a:endParaRPr lang="fr-CA"/>
+            </a:p>
+          </p:txBody>
+        </p:sp>
+      </p:grpSp>
+      <p:grpSp>
+        <p:nvGrpSpPr>
+          <p:cNvPr id="67" name="Group 66">
+            <a:extLst>
+              <a:ext uri="{FF2B5EF4-FFF2-40B4-BE49-F238E27FC236}">
+                <a16:creationId xmlns:a16="http://schemas.microsoft.com/office/drawing/2014/main" id="{70B7A775-3F4C-6D85-9764-FA1DF273B9BF}"/>
+              </a:ext>
+            </a:extLst>
+          </p:cNvPr>
+          <p:cNvGrpSpPr>
+            <a:grpSpLocks noChangeAspect="1"/>
+          </p:cNvGrpSpPr>
+          <p:nvPr/>
+        </p:nvGrpSpPr>
+        <p:grpSpPr>
+          <a:xfrm>
+            <a:off x="5320138" y="4765998"/>
+            <a:ext cx="986198" cy="720000"/>
+            <a:chOff x="4382930" y="1044131"/>
+            <a:chExt cx="5745670" cy="4194779"/>
+          </a:xfrm>
+        </p:grpSpPr>
+        <p:sp>
+          <p:nvSpPr>
+            <p:cNvPr id="68" name="Oval 67">
+              <a:extLst>
+                <a:ext uri="{FF2B5EF4-FFF2-40B4-BE49-F238E27FC236}">
+                  <a16:creationId xmlns:a16="http://schemas.microsoft.com/office/drawing/2014/main" id="{6B2F96EB-FE80-D406-A71E-A97C73A0F481}"/>
+                </a:ext>
+              </a:extLst>
+            </p:cNvPr>
+            <p:cNvSpPr/>
+            <p:nvPr/>
+          </p:nvSpPr>
+          <p:spPr>
+            <a:xfrm>
+              <a:off x="5372454" y="3449130"/>
+              <a:ext cx="1238865" cy="1447335"/>
+            </a:xfrm>
+            <a:prstGeom prst="ellipse">
+              <a:avLst/>
+            </a:prstGeom>
+            <a:solidFill>
+              <a:srgbClr val="333333"/>
+            </a:solidFill>
+          </p:spPr>
+          <p:style>
+            <a:lnRef idx="2">
+              <a:schemeClr val="accent1">
+                <a:shade val="15000"/>
+              </a:schemeClr>
+            </a:lnRef>
+            <a:fillRef idx="1">
+              <a:schemeClr val="accent1"/>
+            </a:fillRef>
+            <a:effectRef idx="0">
+              <a:schemeClr val="accent1"/>
+            </a:effectRef>
+            <a:fontRef idx="minor">
+              <a:schemeClr val="lt1"/>
+            </a:fontRef>
+          </p:style>
+          <p:txBody>
+            <a:bodyPr rtlCol="0" anchor="ctr"/>
+            <a:lstStyle/>
+            <a:p>
+              <a:pPr algn="ctr"/>
+              <a:endParaRPr lang="fr-CA"/>
+            </a:p>
+          </p:txBody>
+        </p:sp>
+        <p:sp>
+          <p:nvSpPr>
+            <p:cNvPr id="69" name="Graphic 14" descr="Lock with solid fill">
+              <a:extLst>
+                <a:ext uri="{FF2B5EF4-FFF2-40B4-BE49-F238E27FC236}">
+                  <a16:creationId xmlns:a16="http://schemas.microsoft.com/office/drawing/2014/main" id="{B9F5F76D-9D29-E743-EC31-A5A8FF2C886E}"/>
+                </a:ext>
+              </a:extLst>
+            </p:cNvPr>
+            <p:cNvSpPr/>
+            <p:nvPr/>
+          </p:nvSpPr>
+          <p:spPr>
+            <a:xfrm>
+              <a:off x="4382930" y="1044131"/>
+              <a:ext cx="3217913" cy="4194779"/>
+            </a:xfrm>
+            <a:custGeom>
+              <a:avLst/>
+              <a:gdLst>
+                <a:gd name="csX0" fmla="*/ 285750 w 533400"/>
+                <a:gd name="csY0" fmla="*/ 549593 h 695325"/>
+                <a:gd name="csX1" fmla="*/ 285750 w 533400"/>
+                <a:gd name="csY1" fmla="*/ 600075 h 695325"/>
+                <a:gd name="csX2" fmla="*/ 247650 w 533400"/>
+                <a:gd name="csY2" fmla="*/ 600075 h 695325"/>
+                <a:gd name="csX3" fmla="*/ 247650 w 533400"/>
+                <a:gd name="csY3" fmla="*/ 549593 h 695325"/>
+                <a:gd name="csX4" fmla="*/ 209550 w 533400"/>
+                <a:gd name="csY4" fmla="*/ 495300 h 695325"/>
+                <a:gd name="csX5" fmla="*/ 266700 w 533400"/>
+                <a:gd name="csY5" fmla="*/ 438150 h 695325"/>
+                <a:gd name="csX6" fmla="*/ 323850 w 533400"/>
+                <a:gd name="csY6" fmla="*/ 495300 h 695325"/>
+                <a:gd name="csX7" fmla="*/ 285750 w 533400"/>
+                <a:gd name="csY7" fmla="*/ 549593 h 695325"/>
+                <a:gd name="csX8" fmla="*/ 123825 w 533400"/>
+                <a:gd name="csY8" fmla="*/ 200025 h 695325"/>
+                <a:gd name="csX9" fmla="*/ 266700 w 533400"/>
+                <a:gd name="csY9" fmla="*/ 57150 h 695325"/>
+                <a:gd name="csX10" fmla="*/ 409575 w 533400"/>
+                <a:gd name="csY10" fmla="*/ 200025 h 695325"/>
+                <a:gd name="csX11" fmla="*/ 409575 w 533400"/>
+                <a:gd name="csY11" fmla="*/ 305753 h 695325"/>
+                <a:gd name="csX12" fmla="*/ 266700 w 533400"/>
+                <a:gd name="csY12" fmla="*/ 295275 h 695325"/>
+                <a:gd name="csX13" fmla="*/ 123825 w 533400"/>
+                <a:gd name="csY13" fmla="*/ 305753 h 695325"/>
+                <a:gd name="csX14" fmla="*/ 123825 w 533400"/>
+                <a:gd name="csY14" fmla="*/ 200025 h 695325"/>
+                <a:gd name="csX15" fmla="*/ 466725 w 533400"/>
+                <a:gd name="csY15" fmla="*/ 309563 h 695325"/>
+                <a:gd name="csX16" fmla="*/ 466725 w 533400"/>
+                <a:gd name="csY16" fmla="*/ 200025 h 695325"/>
+                <a:gd name="csX17" fmla="*/ 266700 w 533400"/>
+                <a:gd name="csY17" fmla="*/ 0 h 695325"/>
+                <a:gd name="csX18" fmla="*/ 66675 w 533400"/>
+                <a:gd name="csY18" fmla="*/ 200025 h 695325"/>
+                <a:gd name="csX19" fmla="*/ 66675 w 533400"/>
+                <a:gd name="csY19" fmla="*/ 309563 h 695325"/>
+                <a:gd name="csX20" fmla="*/ 0 w 533400"/>
+                <a:gd name="csY20" fmla="*/ 314325 h 695325"/>
+                <a:gd name="csX21" fmla="*/ 0 w 533400"/>
+                <a:gd name="csY21" fmla="*/ 676275 h 695325"/>
+                <a:gd name="csX22" fmla="*/ 266700 w 533400"/>
+                <a:gd name="csY22" fmla="*/ 695325 h 695325"/>
+                <a:gd name="csX23" fmla="*/ 533400 w 533400"/>
+                <a:gd name="csY23" fmla="*/ 676275 h 695325"/>
+                <a:gd name="csX24" fmla="*/ 533400 w 533400"/>
+                <a:gd name="csY24" fmla="*/ 314325 h 695325"/>
+                <a:gd name="csX25" fmla="*/ 466725 w 533400"/>
+                <a:gd name="csY25" fmla="*/ 309563 h 695325"/>
+              </a:gdLst>
+              <a:ahLst/>
+              <a:cxnLst>
+                <a:cxn ang="0">
+                  <a:pos x="csX0" y="csY0"/>
+                </a:cxn>
+                <a:cxn ang="0">
+                  <a:pos x="csX1" y="csY1"/>
+                </a:cxn>
+                <a:cxn ang="0">
+                  <a:pos x="csX2" y="csY2"/>
+                </a:cxn>
+                <a:cxn ang="0">
+                  <a:pos x="csX3" y="csY3"/>
+                </a:cxn>
+                <a:cxn ang="0">
+                  <a:pos x="csX4" y="csY4"/>
+                </a:cxn>
+                <a:cxn ang="0">
+                  <a:pos x="csX5" y="csY5"/>
+                </a:cxn>
+                <a:cxn ang="0">
+                  <a:pos x="csX6" y="csY6"/>
+                </a:cxn>
+                <a:cxn ang="0">
+                  <a:pos x="csX7" y="csY7"/>
+                </a:cxn>
+                <a:cxn ang="0">
+                  <a:pos x="csX8" y="csY8"/>
+                </a:cxn>
+                <a:cxn ang="0">
+                  <a:pos x="csX9" y="csY9"/>
+                </a:cxn>
+                <a:cxn ang="0">
+                  <a:pos x="csX10" y="csY10"/>
+                </a:cxn>
+                <a:cxn ang="0">
+                  <a:pos x="csX11" y="csY11"/>
+                </a:cxn>
+                <a:cxn ang="0">
+                  <a:pos x="csX12" y="csY12"/>
+                </a:cxn>
+                <a:cxn ang="0">
+                  <a:pos x="csX13" y="csY13"/>
+                </a:cxn>
+                <a:cxn ang="0">
+                  <a:pos x="csX14" y="csY14"/>
+                </a:cxn>
+                <a:cxn ang="0">
+                  <a:pos x="csX15" y="csY15"/>
+                </a:cxn>
+                <a:cxn ang="0">
+                  <a:pos x="csX16" y="csY16"/>
+                </a:cxn>
+                <a:cxn ang="0">
+                  <a:pos x="csX17" y="csY17"/>
+                </a:cxn>
+                <a:cxn ang="0">
+                  <a:pos x="csX18" y="csY18"/>
+                </a:cxn>
+                <a:cxn ang="0">
+                  <a:pos x="csX19" y="csY19"/>
+                </a:cxn>
+                <a:cxn ang="0">
+                  <a:pos x="csX20" y="csY20"/>
+                </a:cxn>
+                <a:cxn ang="0">
+                  <a:pos x="csX21" y="csY21"/>
+                </a:cxn>
+                <a:cxn ang="0">
+                  <a:pos x="csX22" y="csY22"/>
+                </a:cxn>
+                <a:cxn ang="0">
+                  <a:pos x="csX23" y="csY23"/>
+                </a:cxn>
+                <a:cxn ang="0">
+                  <a:pos x="csX24" y="csY24"/>
+                </a:cxn>
+                <a:cxn ang="0">
+                  <a:pos x="csX25" y="csY25"/>
+                </a:cxn>
+              </a:cxnLst>
+              <a:rect l="l" t="t" r="r" b="b"/>
+              <a:pathLst>
+                <a:path w="533400" h="695325">
+                  <a:moveTo>
+                    <a:pt x="285750" y="549593"/>
+                  </a:moveTo>
+                  <a:lnTo>
+                    <a:pt x="285750" y="600075"/>
+                  </a:lnTo>
+                  <a:lnTo>
+                    <a:pt x="247650" y="600075"/>
+                  </a:lnTo>
+                  <a:lnTo>
+                    <a:pt x="247650" y="549593"/>
+                  </a:lnTo>
+                  <a:cubicBezTo>
+                    <a:pt x="225743" y="541973"/>
+                    <a:pt x="209550" y="521017"/>
+                    <a:pt x="209550" y="495300"/>
+                  </a:cubicBezTo>
+                  <a:cubicBezTo>
+                    <a:pt x="209550" y="463868"/>
+                    <a:pt x="235268" y="438150"/>
+                    <a:pt x="266700" y="438150"/>
+                  </a:cubicBezTo>
+                  <a:cubicBezTo>
+                    <a:pt x="298133" y="438150"/>
+                    <a:pt x="323850" y="463868"/>
+                    <a:pt x="323850" y="495300"/>
+                  </a:cubicBezTo>
+                  <a:cubicBezTo>
+                    <a:pt x="323850" y="520065"/>
+                    <a:pt x="307658" y="541020"/>
+                    <a:pt x="285750" y="549593"/>
+                  </a:cubicBezTo>
+                  <a:close/>
+                  <a:moveTo>
+                    <a:pt x="123825" y="200025"/>
+                  </a:moveTo>
+                  <a:cubicBezTo>
+                    <a:pt x="123825" y="120968"/>
+                    <a:pt x="187643" y="57150"/>
+                    <a:pt x="266700" y="57150"/>
+                  </a:cubicBezTo>
+                  <a:cubicBezTo>
+                    <a:pt x="345758" y="57150"/>
+                    <a:pt x="409575" y="120968"/>
+                    <a:pt x="409575" y="200025"/>
+                  </a:cubicBezTo>
+                  <a:lnTo>
+                    <a:pt x="409575" y="305753"/>
+                  </a:lnTo>
+                  <a:lnTo>
+                    <a:pt x="266700" y="295275"/>
+                  </a:lnTo>
+                  <a:lnTo>
+                    <a:pt x="123825" y="305753"/>
+                  </a:lnTo>
+                  <a:lnTo>
+                    <a:pt x="123825" y="200025"/>
+                  </a:lnTo>
+                  <a:close/>
+                  <a:moveTo>
+                    <a:pt x="466725" y="309563"/>
+                  </a:moveTo>
+                  <a:lnTo>
+                    <a:pt x="466725" y="200025"/>
+                  </a:lnTo>
+                  <a:cubicBezTo>
+                    <a:pt x="466725" y="89535"/>
+                    <a:pt x="377190" y="0"/>
+                    <a:pt x="266700" y="0"/>
+                  </a:cubicBezTo>
+                  <a:cubicBezTo>
+                    <a:pt x="156210" y="0"/>
+                    <a:pt x="66675" y="89535"/>
+                    <a:pt x="66675" y="200025"/>
+                  </a:cubicBezTo>
+                  <a:lnTo>
+                    <a:pt x="66675" y="309563"/>
+                  </a:lnTo>
+                  <a:lnTo>
+                    <a:pt x="0" y="314325"/>
+                  </a:lnTo>
+                  <a:lnTo>
+                    <a:pt x="0" y="676275"/>
+                  </a:lnTo>
+                  <a:lnTo>
+                    <a:pt x="266700" y="695325"/>
+                  </a:lnTo>
+                  <a:lnTo>
+                    <a:pt x="533400" y="676275"/>
+                  </a:lnTo>
+                  <a:lnTo>
+                    <a:pt x="533400" y="314325"/>
+                  </a:lnTo>
+                  <a:lnTo>
+                    <a:pt x="466725" y="309563"/>
+                  </a:lnTo>
+                  <a:close/>
+                </a:path>
+              </a:pathLst>
+            </a:custGeom>
+            <a:solidFill>
+              <a:srgbClr val="CCCCCC"/>
+            </a:solidFill>
+            <a:ln w="9525" cap="flat">
+              <a:noFill/>
+              <a:prstDash val="solid"/>
+              <a:miter/>
+            </a:ln>
+          </p:spPr>
+          <p:txBody>
+            <a:bodyPr/>
+            <a:lstStyle/>
+            <a:p>
+              <a:endParaRPr lang="fr-CA"/>
+            </a:p>
+          </p:txBody>
+        </p:sp>
+        <p:sp>
+          <p:nvSpPr>
+            <p:cNvPr id="70" name="Rectangle 69">
+              <a:extLst>
+                <a:ext uri="{FF2B5EF4-FFF2-40B4-BE49-F238E27FC236}">
+                  <a16:creationId xmlns:a16="http://schemas.microsoft.com/office/drawing/2014/main" id="{7F9A19E6-6F74-523C-60F0-A0662EDE2C11}"/>
+                </a:ext>
+              </a:extLst>
+            </p:cNvPr>
+            <p:cNvSpPr/>
+            <p:nvPr/>
+          </p:nvSpPr>
+          <p:spPr>
+            <a:xfrm>
+              <a:off x="4738785" y="2982771"/>
+              <a:ext cx="2506202" cy="36000"/>
+            </a:xfrm>
+            <a:prstGeom prst="rect">
+              <a:avLst/>
+            </a:prstGeom>
+            <a:solidFill>
+              <a:srgbClr val="999999"/>
+            </a:solidFill>
+            <a:ln>
+              <a:noFill/>
+            </a:ln>
+          </p:spPr>
+          <p:style>
+            <a:lnRef idx="2">
+              <a:schemeClr val="accent1">
+                <a:shade val="15000"/>
+              </a:schemeClr>
+            </a:lnRef>
+            <a:fillRef idx="1">
+              <a:schemeClr val="accent1"/>
+            </a:fillRef>
+            <a:effectRef idx="0">
+              <a:schemeClr val="accent1"/>
+            </a:effectRef>
+            <a:fontRef idx="minor">
+              <a:schemeClr val="lt1"/>
+            </a:fontRef>
+          </p:style>
+          <p:txBody>
+            <a:bodyPr rtlCol="0" anchor="ctr"/>
+            <a:lstStyle/>
+            <a:p>
+              <a:pPr algn="ctr"/>
+              <a:endParaRPr lang="fr-CA"/>
+            </a:p>
+          </p:txBody>
+        </p:sp>
+        <p:sp>
+          <p:nvSpPr>
+            <p:cNvPr id="71" name="Rectangle 70">
+              <a:extLst>
+                <a:ext uri="{FF2B5EF4-FFF2-40B4-BE49-F238E27FC236}">
+                  <a16:creationId xmlns:a16="http://schemas.microsoft.com/office/drawing/2014/main" id="{28C543A9-3CB8-A748-0551-D42E973976C8}"/>
+                </a:ext>
+              </a:extLst>
+            </p:cNvPr>
+            <p:cNvSpPr/>
+            <p:nvPr/>
+          </p:nvSpPr>
+          <p:spPr>
+            <a:xfrm>
+              <a:off x="4738785" y="3292458"/>
+              <a:ext cx="2506202" cy="36000"/>
+            </a:xfrm>
+            <a:prstGeom prst="rect">
+              <a:avLst/>
+            </a:prstGeom>
+            <a:solidFill>
+              <a:srgbClr val="999999"/>
+            </a:solidFill>
+            <a:ln>
+              <a:noFill/>
+            </a:ln>
+          </p:spPr>
+          <p:style>
+            <a:lnRef idx="2">
+              <a:schemeClr val="accent1">
+                <a:shade val="15000"/>
+              </a:schemeClr>
+            </a:lnRef>
+            <a:fillRef idx="1">
+              <a:schemeClr val="accent1"/>
+            </a:fillRef>
+            <a:effectRef idx="0">
+              <a:schemeClr val="accent1"/>
+            </a:effectRef>
+            <a:fontRef idx="minor">
+              <a:schemeClr val="lt1"/>
+            </a:fontRef>
+          </p:style>
+          <p:txBody>
+            <a:bodyPr rtlCol="0" anchor="ctr"/>
+            <a:lstStyle/>
+            <a:p>
+              <a:pPr algn="ctr"/>
+              <a:endParaRPr lang="fr-CA"/>
+            </a:p>
+          </p:txBody>
+        </p:sp>
+        <p:sp>
+          <p:nvSpPr>
+            <p:cNvPr id="72" name="Rectangle 71">
+              <a:extLst>
+                <a:ext uri="{FF2B5EF4-FFF2-40B4-BE49-F238E27FC236}">
+                  <a16:creationId xmlns:a16="http://schemas.microsoft.com/office/drawing/2014/main" id="{6620083A-717F-7D71-8FDC-6AA2899E1617}"/>
+                </a:ext>
+              </a:extLst>
+            </p:cNvPr>
+            <p:cNvSpPr/>
+            <p:nvPr/>
+          </p:nvSpPr>
+          <p:spPr>
+            <a:xfrm>
+              <a:off x="4738785" y="4838668"/>
+              <a:ext cx="2506202" cy="36000"/>
+            </a:xfrm>
+            <a:prstGeom prst="rect">
+              <a:avLst/>
+            </a:prstGeom>
+            <a:solidFill>
+              <a:srgbClr val="999999"/>
+            </a:solidFill>
+            <a:ln>
+              <a:noFill/>
+            </a:ln>
+          </p:spPr>
+          <p:style>
+            <a:lnRef idx="2">
+              <a:schemeClr val="accent1">
+                <a:shade val="15000"/>
+              </a:schemeClr>
+            </a:lnRef>
+            <a:fillRef idx="1">
+              <a:schemeClr val="accent1"/>
+            </a:fillRef>
+            <a:effectRef idx="0">
+              <a:schemeClr val="accent1"/>
+            </a:effectRef>
+            <a:fontRef idx="minor">
+              <a:schemeClr val="lt1"/>
+            </a:fontRef>
+          </p:style>
+          <p:txBody>
+            <a:bodyPr rtlCol="0" anchor="ctr"/>
+            <a:lstStyle/>
+            <a:p>
+              <a:pPr algn="ctr"/>
+              <a:endParaRPr lang="fr-CA"/>
+            </a:p>
+          </p:txBody>
+        </p:sp>
+        <p:sp>
+          <p:nvSpPr>
+            <p:cNvPr id="73" name="Rectangle 72">
+              <a:extLst>
+                <a:ext uri="{FF2B5EF4-FFF2-40B4-BE49-F238E27FC236}">
+                  <a16:creationId xmlns:a16="http://schemas.microsoft.com/office/drawing/2014/main" id="{406C49F0-4D19-61AD-5FCA-10AE919B6D9D}"/>
+                </a:ext>
+              </a:extLst>
+            </p:cNvPr>
+            <p:cNvSpPr/>
+            <p:nvPr/>
+          </p:nvSpPr>
+          <p:spPr>
+            <a:xfrm>
+              <a:off x="4738785" y="3602146"/>
+              <a:ext cx="2506202" cy="36000"/>
+            </a:xfrm>
+            <a:prstGeom prst="rect">
+              <a:avLst/>
+            </a:prstGeom>
+            <a:solidFill>
+              <a:srgbClr val="999999"/>
+            </a:solidFill>
+            <a:ln>
+              <a:noFill/>
+            </a:ln>
+          </p:spPr>
+          <p:style>
+            <a:lnRef idx="2">
+              <a:schemeClr val="accent1">
+                <a:shade val="15000"/>
+              </a:schemeClr>
+            </a:lnRef>
+            <a:fillRef idx="1">
+              <a:schemeClr val="accent1"/>
+            </a:fillRef>
+            <a:effectRef idx="0">
+              <a:schemeClr val="accent1"/>
+            </a:effectRef>
+            <a:fontRef idx="minor">
+              <a:schemeClr val="lt1"/>
+            </a:fontRef>
+          </p:style>
+          <p:txBody>
+            <a:bodyPr rtlCol="0" anchor="ctr"/>
+            <a:lstStyle/>
+            <a:p>
+              <a:pPr algn="ctr"/>
+              <a:endParaRPr lang="fr-CA"/>
+            </a:p>
+          </p:txBody>
+        </p:sp>
+        <p:sp>
+          <p:nvSpPr>
+            <p:cNvPr id="74" name="Oval 73">
+              <a:extLst>
+                <a:ext uri="{FF2B5EF4-FFF2-40B4-BE49-F238E27FC236}">
+                  <a16:creationId xmlns:a16="http://schemas.microsoft.com/office/drawing/2014/main" id="{1288DEFD-D501-8E43-E117-BFB7EBC15C53}"/>
+                </a:ext>
+              </a:extLst>
+            </p:cNvPr>
+            <p:cNvSpPr/>
+            <p:nvPr/>
+          </p:nvSpPr>
+          <p:spPr>
+            <a:xfrm>
+              <a:off x="7968600" y="1794206"/>
+              <a:ext cx="900000" cy="900000"/>
+            </a:xfrm>
+            <a:prstGeom prst="ellipse">
+              <a:avLst/>
+            </a:prstGeom>
+            <a:solidFill>
+              <a:srgbClr val="CCCCCC"/>
+            </a:solidFill>
+            <a:ln>
+              <a:noFill/>
+            </a:ln>
+          </p:spPr>
+          <p:style>
+            <a:lnRef idx="2">
+              <a:schemeClr val="accent1">
+                <a:shade val="15000"/>
+              </a:schemeClr>
+            </a:lnRef>
+            <a:fillRef idx="1">
+              <a:schemeClr val="accent1"/>
+            </a:fillRef>
+            <a:effectRef idx="0">
+              <a:schemeClr val="accent1"/>
+            </a:effectRef>
+            <a:fontRef idx="minor">
+              <a:schemeClr val="lt1"/>
+            </a:fontRef>
+          </p:style>
+          <p:txBody>
+            <a:bodyPr rtlCol="0" anchor="ctr"/>
+            <a:lstStyle/>
+            <a:p>
+              <a:pPr algn="ctr"/>
+              <a:endParaRPr lang="fr-CA"/>
+            </a:p>
+          </p:txBody>
+        </p:sp>
+        <p:sp>
+          <p:nvSpPr>
+            <p:cNvPr id="75" name="Oval 74">
+              <a:extLst>
+                <a:ext uri="{FF2B5EF4-FFF2-40B4-BE49-F238E27FC236}">
+                  <a16:creationId xmlns:a16="http://schemas.microsoft.com/office/drawing/2014/main" id="{B30E1662-5913-3D9C-652C-3BA26825C292}"/>
+                </a:ext>
+              </a:extLst>
+            </p:cNvPr>
+            <p:cNvSpPr/>
+            <p:nvPr/>
+          </p:nvSpPr>
+          <p:spPr>
+            <a:xfrm>
+              <a:off x="7968600" y="3057103"/>
+              <a:ext cx="900000" cy="900000"/>
+            </a:xfrm>
+            <a:prstGeom prst="ellipse">
+              <a:avLst/>
+            </a:prstGeom>
+            <a:solidFill>
+              <a:srgbClr val="999999"/>
+            </a:solidFill>
+            <a:ln>
+              <a:noFill/>
+            </a:ln>
+          </p:spPr>
+          <p:style>
+            <a:lnRef idx="2">
+              <a:schemeClr val="accent1">
+                <a:shade val="15000"/>
+              </a:schemeClr>
+            </a:lnRef>
+            <a:fillRef idx="1">
+              <a:schemeClr val="accent1"/>
+            </a:fillRef>
+            <a:effectRef idx="0">
+              <a:schemeClr val="accent1"/>
+            </a:effectRef>
+            <a:fontRef idx="minor">
+              <a:schemeClr val="lt1"/>
+            </a:fontRef>
+          </p:style>
+          <p:txBody>
+            <a:bodyPr rtlCol="0" anchor="ctr"/>
+            <a:lstStyle/>
+            <a:p>
+              <a:pPr algn="ctr"/>
+              <a:endParaRPr lang="fr-CA"/>
+            </a:p>
+          </p:txBody>
+        </p:sp>
+        <p:sp>
+          <p:nvSpPr>
+            <p:cNvPr id="76" name="Oval 75">
+              <a:extLst>
+                <a:ext uri="{FF2B5EF4-FFF2-40B4-BE49-F238E27FC236}">
+                  <a16:creationId xmlns:a16="http://schemas.microsoft.com/office/drawing/2014/main" id="{563A1BE3-227C-3679-2D29-EE0ED4AAF6A9}"/>
+                </a:ext>
+              </a:extLst>
+            </p:cNvPr>
+            <p:cNvSpPr/>
+            <p:nvPr/>
+          </p:nvSpPr>
+          <p:spPr>
+            <a:xfrm>
+              <a:off x="7968600" y="4320000"/>
+              <a:ext cx="900000" cy="900000"/>
+            </a:xfrm>
+            <a:prstGeom prst="ellipse">
+              <a:avLst/>
+            </a:prstGeom>
+            <a:solidFill>
+              <a:srgbClr val="666666"/>
+            </a:solidFill>
+            <a:ln>
+              <a:noFill/>
+            </a:ln>
+          </p:spPr>
+          <p:style>
+            <a:lnRef idx="2">
+              <a:schemeClr val="accent1">
+                <a:shade val="15000"/>
+              </a:schemeClr>
+            </a:lnRef>
+            <a:fillRef idx="1">
+              <a:schemeClr val="accent1"/>
+            </a:fillRef>
+            <a:effectRef idx="0">
+              <a:schemeClr val="accent1"/>
+            </a:effectRef>
+            <a:fontRef idx="minor">
+              <a:schemeClr val="lt1"/>
+            </a:fontRef>
+          </p:style>
+          <p:txBody>
+            <a:bodyPr rtlCol="0" anchor="ctr"/>
+            <a:lstStyle/>
+            <a:p>
+              <a:pPr algn="ctr"/>
+              <a:endParaRPr lang="fr-CA"/>
+            </a:p>
+          </p:txBody>
+        </p:sp>
+        <p:sp>
+          <p:nvSpPr>
+            <p:cNvPr id="77" name="Oval 76">
+              <a:extLst>
+                <a:ext uri="{FF2B5EF4-FFF2-40B4-BE49-F238E27FC236}">
+                  <a16:creationId xmlns:a16="http://schemas.microsoft.com/office/drawing/2014/main" id="{2C8F58FE-4157-5630-E6DE-0C17A433C07A}"/>
+                </a:ext>
+              </a:extLst>
+            </p:cNvPr>
+            <p:cNvSpPr/>
+            <p:nvPr/>
+          </p:nvSpPr>
+          <p:spPr>
+            <a:xfrm>
+              <a:off x="9228600" y="1796013"/>
+              <a:ext cx="900000" cy="900000"/>
+            </a:xfrm>
+            <a:prstGeom prst="ellipse">
+              <a:avLst/>
+            </a:prstGeom>
+            <a:solidFill>
+              <a:srgbClr val="666666"/>
+            </a:solidFill>
+            <a:ln>
+              <a:noFill/>
+            </a:ln>
+          </p:spPr>
+          <p:style>
+            <a:lnRef idx="2">
+              <a:schemeClr val="accent1">
+                <a:shade val="15000"/>
+              </a:schemeClr>
+            </a:lnRef>
+            <a:fillRef idx="1">
+              <a:schemeClr val="accent1"/>
+            </a:fillRef>
+            <a:effectRef idx="0">
+              <a:schemeClr val="accent1"/>
+            </a:effectRef>
+            <a:fontRef idx="minor">
+              <a:schemeClr val="lt1"/>
+            </a:fontRef>
+          </p:style>
+          <p:txBody>
+            <a:bodyPr rtlCol="0" anchor="ctr"/>
+            <a:lstStyle/>
+            <a:p>
+              <a:pPr algn="ctr"/>
+              <a:endParaRPr lang="fr-CA"/>
+            </a:p>
+          </p:txBody>
+        </p:sp>
+        <p:sp>
+          <p:nvSpPr>
+            <p:cNvPr id="84" name="Oval 83">
+              <a:extLst>
+                <a:ext uri="{FF2B5EF4-FFF2-40B4-BE49-F238E27FC236}">
+                  <a16:creationId xmlns:a16="http://schemas.microsoft.com/office/drawing/2014/main" id="{C198B737-ABC1-C762-B81E-95D438867949}"/>
+                </a:ext>
+              </a:extLst>
+            </p:cNvPr>
+            <p:cNvSpPr/>
+            <p:nvPr/>
+          </p:nvSpPr>
+          <p:spPr>
+            <a:xfrm>
+              <a:off x="9228600" y="3060000"/>
+              <a:ext cx="900000" cy="900000"/>
+            </a:xfrm>
+            <a:prstGeom prst="ellipse">
+              <a:avLst/>
+            </a:prstGeom>
+            <a:solidFill>
+              <a:srgbClr val="999999"/>
+            </a:solidFill>
+            <a:ln>
+              <a:noFill/>
+            </a:ln>
+          </p:spPr>
+          <p:style>
+            <a:lnRef idx="2">
+              <a:schemeClr val="accent1">
+                <a:shade val="15000"/>
+              </a:schemeClr>
+            </a:lnRef>
+            <a:fillRef idx="1">
+              <a:schemeClr val="accent1"/>
+            </a:fillRef>
+            <a:effectRef idx="0">
+              <a:schemeClr val="accent1"/>
+            </a:effectRef>
+            <a:fontRef idx="minor">
+              <a:schemeClr val="lt1"/>
+            </a:fontRef>
+          </p:style>
+          <p:txBody>
+            <a:bodyPr rtlCol="0" anchor="ctr"/>
+            <a:lstStyle/>
+            <a:p>
+              <a:pPr algn="ctr"/>
+              <a:endParaRPr lang="fr-CA"/>
+            </a:p>
+          </p:txBody>
+        </p:sp>
+        <p:sp>
+          <p:nvSpPr>
+            <p:cNvPr id="85" name="Oval 84">
+              <a:extLst>
+                <a:ext uri="{FF2B5EF4-FFF2-40B4-BE49-F238E27FC236}">
+                  <a16:creationId xmlns:a16="http://schemas.microsoft.com/office/drawing/2014/main" id="{59A1F453-0F0D-5311-8924-CF7B21886EEF}"/>
+                </a:ext>
+              </a:extLst>
+            </p:cNvPr>
+            <p:cNvSpPr/>
+            <p:nvPr/>
+          </p:nvSpPr>
+          <p:spPr>
+            <a:xfrm>
+              <a:off x="9228600" y="4320000"/>
+              <a:ext cx="900000" cy="900000"/>
+            </a:xfrm>
+            <a:prstGeom prst="ellipse">
+              <a:avLst/>
+            </a:prstGeom>
+            <a:solidFill>
+              <a:srgbClr val="CCCCCC"/>
+            </a:solidFill>
+            <a:ln>
+              <a:noFill/>
+            </a:ln>
+          </p:spPr>
+          <p:style>
+            <a:lnRef idx="2">
+              <a:schemeClr val="accent1">
+                <a:shade val="15000"/>
+              </a:schemeClr>
+            </a:lnRef>
+            <a:fillRef idx="1">
+              <a:schemeClr val="accent1"/>
+            </a:fillRef>
+            <a:effectRef idx="0">
+              <a:schemeClr val="accent1"/>
+            </a:effectRef>
+            <a:fontRef idx="minor">
+              <a:schemeClr val="lt1"/>
+            </a:fontRef>
+          </p:style>
+          <p:txBody>
+            <a:bodyPr rtlCol="0" anchor="ctr"/>
+            <a:lstStyle/>
+            <a:p>
+              <a:pPr algn="ctr"/>
+              <a:endParaRPr lang="fr-CA"/>
+            </a:p>
+          </p:txBody>
+        </p:sp>
+      </p:grpSp>
     </p:spTree>
     <p:extLst>
       <p:ext uri="{BB962C8B-B14F-4D97-AF65-F5344CB8AC3E}">
@@ -10044,10 +11620,10 @@
       </p:grpSp>
       <p:grpSp>
         <p:nvGrpSpPr>
-          <p:cNvPr id="47" name="Group 46">
+          <p:cNvPr id="19" name="Group 18">
             <a:extLst>
               <a:ext uri="{FF2B5EF4-FFF2-40B4-BE49-F238E27FC236}">
-                <a16:creationId xmlns:a16="http://schemas.microsoft.com/office/drawing/2014/main" id="{E962D614-A401-70C3-1239-3AC060A92253}"/>
+                <a16:creationId xmlns:a16="http://schemas.microsoft.com/office/drawing/2014/main" id="{DC138631-3CA8-1604-F0FC-364586555413}"/>
               </a:ext>
             </a:extLst>
           </p:cNvPr>
@@ -10056,18 +11632,18 @@
         </p:nvGrpSpPr>
         <p:grpSpPr>
           <a:xfrm>
-            <a:off x="5183005" y="451610"/>
-            <a:ext cx="2151245" cy="3592076"/>
-            <a:chOff x="5183005" y="451610"/>
-            <a:chExt cx="2151245" cy="3592076"/>
+            <a:off x="692589" y="2253024"/>
+            <a:ext cx="832242" cy="832242"/>
+            <a:chOff x="1611721" y="3648318"/>
+            <a:chExt cx="2440062" cy="2440062"/>
           </a:xfrm>
         </p:grpSpPr>
         <p:sp>
           <p:nvSpPr>
-            <p:cNvPr id="46" name="Oval 45">
+            <p:cNvPr id="20" name="Rectangle 19">
               <a:extLst>
                 <a:ext uri="{FF2B5EF4-FFF2-40B4-BE49-F238E27FC236}">
-                  <a16:creationId xmlns:a16="http://schemas.microsoft.com/office/drawing/2014/main" id="{547D310F-E481-EEAD-DBFF-9F3F94B48743}"/>
+                  <a16:creationId xmlns:a16="http://schemas.microsoft.com/office/drawing/2014/main" id="{C3CE23FB-AFDB-44DC-32D0-55FA939FF209}"/>
                 </a:ext>
               </a:extLst>
             </p:cNvPr>
@@ -10076,8 +11652,1277 @@
           </p:nvSpPr>
           <p:spPr>
             <a:xfrm>
-              <a:off x="5715000" y="2997200"/>
-              <a:ext cx="825500" cy="901700"/>
+              <a:off x="2331720" y="4777740"/>
+              <a:ext cx="1158240" cy="1013460"/>
+            </a:xfrm>
+            <a:prstGeom prst="rect">
+              <a:avLst/>
+            </a:prstGeom>
+            <a:solidFill>
+              <a:srgbClr val="999999"/>
+            </a:solidFill>
+          </p:spPr>
+          <p:style>
+            <a:lnRef idx="2">
+              <a:schemeClr val="accent1">
+                <a:shade val="15000"/>
+              </a:schemeClr>
+            </a:lnRef>
+            <a:fillRef idx="1">
+              <a:schemeClr val="accent1"/>
+            </a:fillRef>
+            <a:effectRef idx="0">
+              <a:schemeClr val="accent1"/>
+            </a:effectRef>
+            <a:fontRef idx="minor">
+              <a:schemeClr val="lt1"/>
+            </a:fontRef>
+          </p:style>
+          <p:txBody>
+            <a:bodyPr rtlCol="0" anchor="ctr"/>
+            <a:lstStyle/>
+            <a:p>
+              <a:pPr algn="ctr"/>
+              <a:endParaRPr lang="fr-CA"/>
+            </a:p>
+          </p:txBody>
+        </p:sp>
+        <p:sp>
+          <p:nvSpPr>
+            <p:cNvPr id="21" name="Rectangle 20">
+              <a:extLst>
+                <a:ext uri="{FF2B5EF4-FFF2-40B4-BE49-F238E27FC236}">
+                  <a16:creationId xmlns:a16="http://schemas.microsoft.com/office/drawing/2014/main" id="{68D04D74-C250-873A-D00A-EC8784736892}"/>
+                </a:ext>
+              </a:extLst>
+            </p:cNvPr>
+            <p:cNvSpPr/>
+            <p:nvPr/>
+          </p:nvSpPr>
+          <p:spPr>
+            <a:xfrm>
+              <a:off x="2103120" y="3764280"/>
+              <a:ext cx="1501140" cy="1013460"/>
+            </a:xfrm>
+            <a:prstGeom prst="rect">
+              <a:avLst/>
+            </a:prstGeom>
+            <a:solidFill>
+              <a:schemeClr val="bg1"/>
+            </a:solidFill>
+          </p:spPr>
+          <p:style>
+            <a:lnRef idx="2">
+              <a:schemeClr val="accent1">
+                <a:shade val="15000"/>
+              </a:schemeClr>
+            </a:lnRef>
+            <a:fillRef idx="1">
+              <a:schemeClr val="accent1"/>
+            </a:fillRef>
+            <a:effectRef idx="0">
+              <a:schemeClr val="accent1"/>
+            </a:effectRef>
+            <a:fontRef idx="minor">
+              <a:schemeClr val="lt1"/>
+            </a:fontRef>
+          </p:style>
+          <p:txBody>
+            <a:bodyPr rtlCol="0" anchor="ctr"/>
+            <a:lstStyle/>
+            <a:p>
+              <a:pPr algn="ctr"/>
+              <a:endParaRPr lang="fr-CA"/>
+            </a:p>
+          </p:txBody>
+        </p:sp>
+        <p:sp>
+          <p:nvSpPr>
+            <p:cNvPr id="22" name="Freeform: Shape 21">
+              <a:extLst>
+                <a:ext uri="{FF2B5EF4-FFF2-40B4-BE49-F238E27FC236}">
+                  <a16:creationId xmlns:a16="http://schemas.microsoft.com/office/drawing/2014/main" id="{737B7A3C-5082-832B-9A9E-575E199D34D6}"/>
+                </a:ext>
+              </a:extLst>
+            </p:cNvPr>
+            <p:cNvSpPr/>
+            <p:nvPr/>
+          </p:nvSpPr>
+          <p:spPr>
+            <a:xfrm>
+              <a:off x="1611721" y="3648318"/>
+              <a:ext cx="2440062" cy="2440062"/>
+            </a:xfrm>
+            <a:custGeom>
+              <a:avLst/>
+              <a:gdLst>
+                <a:gd name="csX0" fmla="*/ 295275 w 647700"/>
+                <a:gd name="csY0" fmla="*/ 400050 h 647700"/>
+                <a:gd name="csX1" fmla="*/ 352425 w 647700"/>
+                <a:gd name="csY1" fmla="*/ 400050 h 647700"/>
+                <a:gd name="csX2" fmla="*/ 352425 w 647700"/>
+                <a:gd name="csY2" fmla="*/ 457200 h 647700"/>
+                <a:gd name="csX3" fmla="*/ 295275 w 647700"/>
+                <a:gd name="csY3" fmla="*/ 457200 h 647700"/>
+                <a:gd name="csX4" fmla="*/ 323850 w 647700"/>
+                <a:gd name="csY4" fmla="*/ 333375 h 647700"/>
+                <a:gd name="csX5" fmla="*/ 228600 w 647700"/>
+                <a:gd name="csY5" fmla="*/ 428625 h 647700"/>
+                <a:gd name="csX6" fmla="*/ 323850 w 647700"/>
+                <a:gd name="csY6" fmla="*/ 523875 h 647700"/>
+                <a:gd name="csX7" fmla="*/ 419100 w 647700"/>
+                <a:gd name="csY7" fmla="*/ 428625 h 647700"/>
+                <a:gd name="csX8" fmla="*/ 323850 w 647700"/>
+                <a:gd name="csY8" fmla="*/ 333375 h 647700"/>
+                <a:gd name="csX9" fmla="*/ 190500 w 647700"/>
+                <a:gd name="csY9" fmla="*/ 95250 h 647700"/>
+                <a:gd name="csX10" fmla="*/ 247650 w 647700"/>
+                <a:gd name="csY10" fmla="*/ 95250 h 647700"/>
+                <a:gd name="csX11" fmla="*/ 247650 w 647700"/>
+                <a:gd name="csY11" fmla="*/ 238125 h 647700"/>
+                <a:gd name="csX12" fmla="*/ 190500 w 647700"/>
+                <a:gd name="csY12" fmla="*/ 238125 h 647700"/>
+                <a:gd name="csX13" fmla="*/ 152400 w 647700"/>
+                <a:gd name="csY13" fmla="*/ 57150 h 647700"/>
+                <a:gd name="csX14" fmla="*/ 152400 w 647700"/>
+                <a:gd name="csY14" fmla="*/ 276225 h 647700"/>
+                <a:gd name="csX15" fmla="*/ 495300 w 647700"/>
+                <a:gd name="csY15" fmla="*/ 276225 h 647700"/>
+                <a:gd name="csX16" fmla="*/ 495300 w 647700"/>
+                <a:gd name="csY16" fmla="*/ 57150 h 647700"/>
+                <a:gd name="csX17" fmla="*/ 95250 w 647700"/>
+                <a:gd name="csY17" fmla="*/ 0 h 647700"/>
+                <a:gd name="csX18" fmla="*/ 152400 w 647700"/>
+                <a:gd name="csY18" fmla="*/ 0 h 647700"/>
+                <a:gd name="csX19" fmla="*/ 495300 w 647700"/>
+                <a:gd name="csY19" fmla="*/ 0 h 647700"/>
+                <a:gd name="csX20" fmla="*/ 609600 w 647700"/>
+                <a:gd name="csY20" fmla="*/ 0 h 647700"/>
+                <a:gd name="csX21" fmla="*/ 647700 w 647700"/>
+                <a:gd name="csY21" fmla="*/ 38100 h 647700"/>
+                <a:gd name="csX22" fmla="*/ 647700 w 647700"/>
+                <a:gd name="csY22" fmla="*/ 609600 h 647700"/>
+                <a:gd name="csX23" fmla="*/ 609600 w 647700"/>
+                <a:gd name="csY23" fmla="*/ 647700 h 647700"/>
+                <a:gd name="csX24" fmla="*/ 38100 w 647700"/>
+                <a:gd name="csY24" fmla="*/ 647700 h 647700"/>
+                <a:gd name="csX25" fmla="*/ 0 w 647700"/>
+                <a:gd name="csY25" fmla="*/ 609600 h 647700"/>
+                <a:gd name="csX26" fmla="*/ 0 w 647700"/>
+                <a:gd name="csY26" fmla="*/ 95250 h 647700"/>
+              </a:gdLst>
+              <a:ahLst/>
+              <a:cxnLst>
+                <a:cxn ang="0">
+                  <a:pos x="csX0" y="csY0"/>
+                </a:cxn>
+                <a:cxn ang="0">
+                  <a:pos x="csX1" y="csY1"/>
+                </a:cxn>
+                <a:cxn ang="0">
+                  <a:pos x="csX2" y="csY2"/>
+                </a:cxn>
+                <a:cxn ang="0">
+                  <a:pos x="csX3" y="csY3"/>
+                </a:cxn>
+                <a:cxn ang="0">
+                  <a:pos x="csX4" y="csY4"/>
+                </a:cxn>
+                <a:cxn ang="0">
+                  <a:pos x="csX5" y="csY5"/>
+                </a:cxn>
+                <a:cxn ang="0">
+                  <a:pos x="csX6" y="csY6"/>
+                </a:cxn>
+                <a:cxn ang="0">
+                  <a:pos x="csX7" y="csY7"/>
+                </a:cxn>
+                <a:cxn ang="0">
+                  <a:pos x="csX8" y="csY8"/>
+                </a:cxn>
+                <a:cxn ang="0">
+                  <a:pos x="csX9" y="csY9"/>
+                </a:cxn>
+                <a:cxn ang="0">
+                  <a:pos x="csX10" y="csY10"/>
+                </a:cxn>
+                <a:cxn ang="0">
+                  <a:pos x="csX11" y="csY11"/>
+                </a:cxn>
+                <a:cxn ang="0">
+                  <a:pos x="csX12" y="csY12"/>
+                </a:cxn>
+                <a:cxn ang="0">
+                  <a:pos x="csX13" y="csY13"/>
+                </a:cxn>
+                <a:cxn ang="0">
+                  <a:pos x="csX14" y="csY14"/>
+                </a:cxn>
+                <a:cxn ang="0">
+                  <a:pos x="csX15" y="csY15"/>
+                </a:cxn>
+                <a:cxn ang="0">
+                  <a:pos x="csX16" y="csY16"/>
+                </a:cxn>
+                <a:cxn ang="0">
+                  <a:pos x="csX17" y="csY17"/>
+                </a:cxn>
+                <a:cxn ang="0">
+                  <a:pos x="csX18" y="csY18"/>
+                </a:cxn>
+                <a:cxn ang="0">
+                  <a:pos x="csX19" y="csY19"/>
+                </a:cxn>
+                <a:cxn ang="0">
+                  <a:pos x="csX20" y="csY20"/>
+                </a:cxn>
+                <a:cxn ang="0">
+                  <a:pos x="csX21" y="csY21"/>
+                </a:cxn>
+                <a:cxn ang="0">
+                  <a:pos x="csX22" y="csY22"/>
+                </a:cxn>
+                <a:cxn ang="0">
+                  <a:pos x="csX23" y="csY23"/>
+                </a:cxn>
+                <a:cxn ang="0">
+                  <a:pos x="csX24" y="csY24"/>
+                </a:cxn>
+                <a:cxn ang="0">
+                  <a:pos x="csX25" y="csY25"/>
+                </a:cxn>
+                <a:cxn ang="0">
+                  <a:pos x="csX26" y="csY26"/>
+                </a:cxn>
+              </a:cxnLst>
+              <a:rect l="l" t="t" r="r" b="b"/>
+              <a:pathLst>
+                <a:path w="647700" h="647700">
+                  <a:moveTo>
+                    <a:pt x="295275" y="400050"/>
+                  </a:moveTo>
+                  <a:lnTo>
+                    <a:pt x="352425" y="400050"/>
+                  </a:lnTo>
+                  <a:lnTo>
+                    <a:pt x="352425" y="457200"/>
+                  </a:lnTo>
+                  <a:lnTo>
+                    <a:pt x="295275" y="457200"/>
+                  </a:lnTo>
+                  <a:close/>
+                  <a:moveTo>
+                    <a:pt x="323850" y="333375"/>
+                  </a:moveTo>
+                  <a:cubicBezTo>
+                    <a:pt x="271463" y="333375"/>
+                    <a:pt x="228600" y="376238"/>
+                    <a:pt x="228600" y="428625"/>
+                  </a:cubicBezTo>
+                  <a:cubicBezTo>
+                    <a:pt x="228600" y="481013"/>
+                    <a:pt x="271463" y="523875"/>
+                    <a:pt x="323850" y="523875"/>
+                  </a:cubicBezTo>
+                  <a:cubicBezTo>
+                    <a:pt x="376238" y="523875"/>
+                    <a:pt x="419100" y="481013"/>
+                    <a:pt x="419100" y="428625"/>
+                  </a:cubicBezTo>
+                  <a:cubicBezTo>
+                    <a:pt x="419100" y="376238"/>
+                    <a:pt x="376238" y="333375"/>
+                    <a:pt x="323850" y="333375"/>
+                  </a:cubicBezTo>
+                  <a:close/>
+                  <a:moveTo>
+                    <a:pt x="190500" y="95250"/>
+                  </a:moveTo>
+                  <a:lnTo>
+                    <a:pt x="247650" y="95250"/>
+                  </a:lnTo>
+                  <a:lnTo>
+                    <a:pt x="247650" y="238125"/>
+                  </a:lnTo>
+                  <a:lnTo>
+                    <a:pt x="190500" y="238125"/>
+                  </a:lnTo>
+                  <a:close/>
+                  <a:moveTo>
+                    <a:pt x="152400" y="57150"/>
+                  </a:moveTo>
+                  <a:lnTo>
+                    <a:pt x="152400" y="276225"/>
+                  </a:lnTo>
+                  <a:lnTo>
+                    <a:pt x="495300" y="276225"/>
+                  </a:lnTo>
+                  <a:lnTo>
+                    <a:pt x="495300" y="57150"/>
+                  </a:lnTo>
+                  <a:close/>
+                  <a:moveTo>
+                    <a:pt x="95250" y="0"/>
+                  </a:moveTo>
+                  <a:lnTo>
+                    <a:pt x="152400" y="0"/>
+                  </a:lnTo>
+                  <a:lnTo>
+                    <a:pt x="495300" y="0"/>
+                  </a:lnTo>
+                  <a:lnTo>
+                    <a:pt x="609600" y="0"/>
+                  </a:lnTo>
+                  <a:cubicBezTo>
+                    <a:pt x="630555" y="0"/>
+                    <a:pt x="647700" y="17145"/>
+                    <a:pt x="647700" y="38100"/>
+                  </a:cubicBezTo>
+                  <a:lnTo>
+                    <a:pt x="647700" y="609600"/>
+                  </a:lnTo>
+                  <a:cubicBezTo>
+                    <a:pt x="647700" y="630555"/>
+                    <a:pt x="630555" y="647700"/>
+                    <a:pt x="609600" y="647700"/>
+                  </a:cubicBezTo>
+                  <a:lnTo>
+                    <a:pt x="38100" y="647700"/>
+                  </a:lnTo>
+                  <a:cubicBezTo>
+                    <a:pt x="17145" y="647700"/>
+                    <a:pt x="0" y="630555"/>
+                    <a:pt x="0" y="609600"/>
+                  </a:cubicBezTo>
+                  <a:lnTo>
+                    <a:pt x="0" y="95250"/>
+                  </a:lnTo>
+                  <a:close/>
+                </a:path>
+              </a:pathLst>
+            </a:custGeom>
+            <a:solidFill>
+              <a:srgbClr val="333333"/>
+            </a:solidFill>
+            <a:ln w="9525" cap="flat">
+              <a:noFill/>
+              <a:prstDash val="solid"/>
+              <a:miter/>
+            </a:ln>
+          </p:spPr>
+          <p:txBody>
+            <a:bodyPr wrap="square">
+              <a:noAutofit/>
+            </a:bodyPr>
+            <a:lstStyle/>
+            <a:p>
+              <a:endParaRPr lang="fr-CA"/>
+            </a:p>
+          </p:txBody>
+        </p:sp>
+      </p:grpSp>
+      <p:grpSp>
+        <p:nvGrpSpPr>
+          <p:cNvPr id="32" name="Group 31">
+            <a:extLst>
+              <a:ext uri="{FF2B5EF4-FFF2-40B4-BE49-F238E27FC236}">
+                <a16:creationId xmlns:a16="http://schemas.microsoft.com/office/drawing/2014/main" id="{62CD0A0B-9942-0265-E9C9-0638152FCD28}"/>
+              </a:ext>
+            </a:extLst>
+          </p:cNvPr>
+          <p:cNvGrpSpPr>
+            <a:grpSpLocks noChangeAspect="1"/>
+          </p:cNvGrpSpPr>
+          <p:nvPr/>
+        </p:nvGrpSpPr>
+        <p:grpSpPr>
+          <a:xfrm>
+            <a:off x="715926" y="3310235"/>
+            <a:ext cx="964747" cy="828000"/>
+            <a:chOff x="3600000" y="2709000"/>
+            <a:chExt cx="2520000" cy="2162806"/>
+          </a:xfrm>
+        </p:grpSpPr>
+        <p:sp>
+          <p:nvSpPr>
+            <p:cNvPr id="33" name="Rectangle 32">
+              <a:extLst>
+                <a:ext uri="{FF2B5EF4-FFF2-40B4-BE49-F238E27FC236}">
+                  <a16:creationId xmlns:a16="http://schemas.microsoft.com/office/drawing/2014/main" id="{A2EB0902-8CD1-43A5-69E3-FCA95DDB8921}"/>
+                </a:ext>
+              </a:extLst>
+            </p:cNvPr>
+            <p:cNvSpPr/>
+            <p:nvPr/>
+          </p:nvSpPr>
+          <p:spPr>
+            <a:xfrm>
+              <a:off x="3600000" y="4149000"/>
+              <a:ext cx="360000" cy="720000"/>
+            </a:xfrm>
+            <a:prstGeom prst="rect">
+              <a:avLst/>
+            </a:prstGeom>
+            <a:solidFill>
+              <a:srgbClr val="333333"/>
+            </a:solidFill>
+            <a:ln>
+              <a:noFill/>
+            </a:ln>
+          </p:spPr>
+          <p:style>
+            <a:lnRef idx="2">
+              <a:schemeClr val="accent1">
+                <a:shade val="15000"/>
+              </a:schemeClr>
+            </a:lnRef>
+            <a:fillRef idx="1">
+              <a:schemeClr val="accent1"/>
+            </a:fillRef>
+            <a:effectRef idx="0">
+              <a:schemeClr val="accent1"/>
+            </a:effectRef>
+            <a:fontRef idx="minor">
+              <a:schemeClr val="lt1"/>
+            </a:fontRef>
+          </p:style>
+          <p:txBody>
+            <a:bodyPr rtlCol="0" anchor="ctr"/>
+            <a:lstStyle/>
+            <a:p>
+              <a:pPr algn="ctr"/>
+              <a:endParaRPr lang="fr-CA"/>
+            </a:p>
+          </p:txBody>
+        </p:sp>
+        <p:sp>
+          <p:nvSpPr>
+            <p:cNvPr id="34" name="Rectangle 33">
+              <a:extLst>
+                <a:ext uri="{FF2B5EF4-FFF2-40B4-BE49-F238E27FC236}">
+                  <a16:creationId xmlns:a16="http://schemas.microsoft.com/office/drawing/2014/main" id="{CC308CC2-2771-4183-D982-ECAD4868C217}"/>
+                </a:ext>
+              </a:extLst>
+            </p:cNvPr>
+            <p:cNvSpPr/>
+            <p:nvPr/>
+          </p:nvSpPr>
+          <p:spPr>
+            <a:xfrm>
+              <a:off x="4140000" y="3789000"/>
+              <a:ext cx="360000" cy="1080000"/>
+            </a:xfrm>
+            <a:prstGeom prst="rect">
+              <a:avLst/>
+            </a:prstGeom>
+            <a:solidFill>
+              <a:srgbClr val="666666"/>
+            </a:solidFill>
+            <a:ln>
+              <a:noFill/>
+            </a:ln>
+          </p:spPr>
+          <p:style>
+            <a:lnRef idx="2">
+              <a:schemeClr val="accent1">
+                <a:shade val="15000"/>
+              </a:schemeClr>
+            </a:lnRef>
+            <a:fillRef idx="1">
+              <a:schemeClr val="accent1"/>
+            </a:fillRef>
+            <a:effectRef idx="0">
+              <a:schemeClr val="accent1"/>
+            </a:effectRef>
+            <a:fontRef idx="minor">
+              <a:schemeClr val="lt1"/>
+            </a:fontRef>
+          </p:style>
+          <p:txBody>
+            <a:bodyPr rtlCol="0" anchor="ctr"/>
+            <a:lstStyle/>
+            <a:p>
+              <a:pPr algn="ctr"/>
+              <a:endParaRPr lang="fr-CA"/>
+            </a:p>
+          </p:txBody>
+        </p:sp>
+        <p:sp>
+          <p:nvSpPr>
+            <p:cNvPr id="35" name="Rectangle 34">
+              <a:extLst>
+                <a:ext uri="{FF2B5EF4-FFF2-40B4-BE49-F238E27FC236}">
+                  <a16:creationId xmlns:a16="http://schemas.microsoft.com/office/drawing/2014/main" id="{825F8DC2-7C87-18F8-1DBE-C1CFA875FDCE}"/>
+                </a:ext>
+              </a:extLst>
+            </p:cNvPr>
+            <p:cNvSpPr/>
+            <p:nvPr/>
+          </p:nvSpPr>
+          <p:spPr>
+            <a:xfrm>
+              <a:off x="4680000" y="3429000"/>
+              <a:ext cx="360000" cy="1440000"/>
+            </a:xfrm>
+            <a:prstGeom prst="rect">
+              <a:avLst/>
+            </a:prstGeom>
+            <a:solidFill>
+              <a:srgbClr val="999999"/>
+            </a:solidFill>
+            <a:ln>
+              <a:noFill/>
+            </a:ln>
+          </p:spPr>
+          <p:style>
+            <a:lnRef idx="2">
+              <a:schemeClr val="accent1">
+                <a:shade val="15000"/>
+              </a:schemeClr>
+            </a:lnRef>
+            <a:fillRef idx="1">
+              <a:schemeClr val="accent1"/>
+            </a:fillRef>
+            <a:effectRef idx="0">
+              <a:schemeClr val="accent1"/>
+            </a:effectRef>
+            <a:fontRef idx="minor">
+              <a:schemeClr val="lt1"/>
+            </a:fontRef>
+          </p:style>
+          <p:txBody>
+            <a:bodyPr rtlCol="0" anchor="ctr"/>
+            <a:lstStyle/>
+            <a:p>
+              <a:pPr algn="ctr"/>
+              <a:endParaRPr lang="fr-CA"/>
+            </a:p>
+          </p:txBody>
+        </p:sp>
+        <p:sp>
+          <p:nvSpPr>
+            <p:cNvPr id="36" name="Rectangle 35">
+              <a:extLst>
+                <a:ext uri="{FF2B5EF4-FFF2-40B4-BE49-F238E27FC236}">
+                  <a16:creationId xmlns:a16="http://schemas.microsoft.com/office/drawing/2014/main" id="{84F7DEDF-245A-6216-5C41-1D30AE540C82}"/>
+                </a:ext>
+              </a:extLst>
+            </p:cNvPr>
+            <p:cNvSpPr/>
+            <p:nvPr/>
+          </p:nvSpPr>
+          <p:spPr>
+            <a:xfrm>
+              <a:off x="5220000" y="3071806"/>
+              <a:ext cx="360000" cy="1800000"/>
+            </a:xfrm>
+            <a:prstGeom prst="rect">
+              <a:avLst/>
+            </a:prstGeom>
+            <a:solidFill>
+              <a:srgbClr val="CCCCCC"/>
+            </a:solidFill>
+            <a:ln>
+              <a:noFill/>
+            </a:ln>
+          </p:spPr>
+          <p:style>
+            <a:lnRef idx="2">
+              <a:schemeClr val="accent1">
+                <a:shade val="15000"/>
+              </a:schemeClr>
+            </a:lnRef>
+            <a:fillRef idx="1">
+              <a:schemeClr val="accent1"/>
+            </a:fillRef>
+            <a:effectRef idx="0">
+              <a:schemeClr val="accent1"/>
+            </a:effectRef>
+            <a:fontRef idx="minor">
+              <a:schemeClr val="lt1"/>
+            </a:fontRef>
+          </p:style>
+          <p:txBody>
+            <a:bodyPr rtlCol="0" anchor="ctr"/>
+            <a:lstStyle/>
+            <a:p>
+              <a:pPr algn="ctr"/>
+              <a:endParaRPr lang="fr-CA"/>
+            </a:p>
+          </p:txBody>
+        </p:sp>
+        <p:sp>
+          <p:nvSpPr>
+            <p:cNvPr id="37" name="Rectangle 36">
+              <a:extLst>
+                <a:ext uri="{FF2B5EF4-FFF2-40B4-BE49-F238E27FC236}">
+                  <a16:creationId xmlns:a16="http://schemas.microsoft.com/office/drawing/2014/main" id="{D23A2FF0-536B-6AFA-2608-72AC2B3D2C34}"/>
+                </a:ext>
+              </a:extLst>
+            </p:cNvPr>
+            <p:cNvSpPr/>
+            <p:nvPr/>
+          </p:nvSpPr>
+          <p:spPr>
+            <a:xfrm>
+              <a:off x="5760000" y="2709000"/>
+              <a:ext cx="360000" cy="2160000"/>
+            </a:xfrm>
+            <a:prstGeom prst="rect">
+              <a:avLst/>
+            </a:prstGeom>
+            <a:solidFill>
+              <a:srgbClr val="FFFFFF"/>
+            </a:solidFill>
+            <a:ln>
+              <a:noFill/>
+            </a:ln>
+          </p:spPr>
+          <p:style>
+            <a:lnRef idx="2">
+              <a:schemeClr val="accent1">
+                <a:shade val="15000"/>
+              </a:schemeClr>
+            </a:lnRef>
+            <a:fillRef idx="1">
+              <a:schemeClr val="accent1"/>
+            </a:fillRef>
+            <a:effectRef idx="0">
+              <a:schemeClr val="accent1"/>
+            </a:effectRef>
+            <a:fontRef idx="minor">
+              <a:schemeClr val="lt1"/>
+            </a:fontRef>
+          </p:style>
+          <p:txBody>
+            <a:bodyPr rtlCol="0" anchor="ctr"/>
+            <a:lstStyle/>
+            <a:p>
+              <a:pPr algn="ctr"/>
+              <a:endParaRPr lang="fr-CA"/>
+            </a:p>
+          </p:txBody>
+        </p:sp>
+      </p:grpSp>
+      <p:grpSp>
+        <p:nvGrpSpPr>
+          <p:cNvPr id="52" name="Group 51">
+            <a:extLst>
+              <a:ext uri="{FF2B5EF4-FFF2-40B4-BE49-F238E27FC236}">
+                <a16:creationId xmlns:a16="http://schemas.microsoft.com/office/drawing/2014/main" id="{8A14AC3F-6CFC-1346-3FA4-65BEC42BEE9B}"/>
+              </a:ext>
+            </a:extLst>
+          </p:cNvPr>
+          <p:cNvGrpSpPr/>
+          <p:nvPr/>
+        </p:nvGrpSpPr>
+        <p:grpSpPr>
+          <a:xfrm>
+            <a:off x="4382930" y="1044131"/>
+            <a:ext cx="5745670" cy="4194779"/>
+            <a:chOff x="4382930" y="1044131"/>
+            <a:chExt cx="5745670" cy="4194779"/>
+          </a:xfrm>
+        </p:grpSpPr>
+        <p:sp>
+          <p:nvSpPr>
+            <p:cNvPr id="38" name="Oval 37">
+              <a:extLst>
+                <a:ext uri="{FF2B5EF4-FFF2-40B4-BE49-F238E27FC236}">
+                  <a16:creationId xmlns:a16="http://schemas.microsoft.com/office/drawing/2014/main" id="{FCCF40CD-B47D-D594-0383-1B6D32B1BCCB}"/>
+                </a:ext>
+              </a:extLst>
+            </p:cNvPr>
+            <p:cNvSpPr/>
+            <p:nvPr/>
+          </p:nvSpPr>
+          <p:spPr>
+            <a:xfrm>
+              <a:off x="5372454" y="3449130"/>
+              <a:ext cx="1238865" cy="1447335"/>
+            </a:xfrm>
+            <a:prstGeom prst="ellipse">
+              <a:avLst/>
+            </a:prstGeom>
+            <a:solidFill>
+              <a:srgbClr val="333333"/>
+            </a:solidFill>
+          </p:spPr>
+          <p:style>
+            <a:lnRef idx="2">
+              <a:schemeClr val="accent1">
+                <a:shade val="15000"/>
+              </a:schemeClr>
+            </a:lnRef>
+            <a:fillRef idx="1">
+              <a:schemeClr val="accent1"/>
+            </a:fillRef>
+            <a:effectRef idx="0">
+              <a:schemeClr val="accent1"/>
+            </a:effectRef>
+            <a:fontRef idx="minor">
+              <a:schemeClr val="lt1"/>
+            </a:fontRef>
+          </p:style>
+          <p:txBody>
+            <a:bodyPr rtlCol="0" anchor="ctr"/>
+            <a:lstStyle/>
+            <a:p>
+              <a:pPr algn="ctr"/>
+              <a:endParaRPr lang="fr-CA"/>
+            </a:p>
+          </p:txBody>
+        </p:sp>
+        <p:sp>
+          <p:nvSpPr>
+            <p:cNvPr id="18" name="Graphic 14" descr="Lock with solid fill">
+              <a:extLst>
+                <a:ext uri="{FF2B5EF4-FFF2-40B4-BE49-F238E27FC236}">
+                  <a16:creationId xmlns:a16="http://schemas.microsoft.com/office/drawing/2014/main" id="{B8CC38D9-BE96-77C7-FE14-B6EDB06094BA}"/>
+                </a:ext>
+              </a:extLst>
+            </p:cNvPr>
+            <p:cNvSpPr/>
+            <p:nvPr/>
+          </p:nvSpPr>
+          <p:spPr>
+            <a:xfrm>
+              <a:off x="4382930" y="1044131"/>
+              <a:ext cx="3217913" cy="4194779"/>
+            </a:xfrm>
+            <a:custGeom>
+              <a:avLst/>
+              <a:gdLst>
+                <a:gd name="csX0" fmla="*/ 285750 w 533400"/>
+                <a:gd name="csY0" fmla="*/ 549593 h 695325"/>
+                <a:gd name="csX1" fmla="*/ 285750 w 533400"/>
+                <a:gd name="csY1" fmla="*/ 600075 h 695325"/>
+                <a:gd name="csX2" fmla="*/ 247650 w 533400"/>
+                <a:gd name="csY2" fmla="*/ 600075 h 695325"/>
+                <a:gd name="csX3" fmla="*/ 247650 w 533400"/>
+                <a:gd name="csY3" fmla="*/ 549593 h 695325"/>
+                <a:gd name="csX4" fmla="*/ 209550 w 533400"/>
+                <a:gd name="csY4" fmla="*/ 495300 h 695325"/>
+                <a:gd name="csX5" fmla="*/ 266700 w 533400"/>
+                <a:gd name="csY5" fmla="*/ 438150 h 695325"/>
+                <a:gd name="csX6" fmla="*/ 323850 w 533400"/>
+                <a:gd name="csY6" fmla="*/ 495300 h 695325"/>
+                <a:gd name="csX7" fmla="*/ 285750 w 533400"/>
+                <a:gd name="csY7" fmla="*/ 549593 h 695325"/>
+                <a:gd name="csX8" fmla="*/ 123825 w 533400"/>
+                <a:gd name="csY8" fmla="*/ 200025 h 695325"/>
+                <a:gd name="csX9" fmla="*/ 266700 w 533400"/>
+                <a:gd name="csY9" fmla="*/ 57150 h 695325"/>
+                <a:gd name="csX10" fmla="*/ 409575 w 533400"/>
+                <a:gd name="csY10" fmla="*/ 200025 h 695325"/>
+                <a:gd name="csX11" fmla="*/ 409575 w 533400"/>
+                <a:gd name="csY11" fmla="*/ 305753 h 695325"/>
+                <a:gd name="csX12" fmla="*/ 266700 w 533400"/>
+                <a:gd name="csY12" fmla="*/ 295275 h 695325"/>
+                <a:gd name="csX13" fmla="*/ 123825 w 533400"/>
+                <a:gd name="csY13" fmla="*/ 305753 h 695325"/>
+                <a:gd name="csX14" fmla="*/ 123825 w 533400"/>
+                <a:gd name="csY14" fmla="*/ 200025 h 695325"/>
+                <a:gd name="csX15" fmla="*/ 466725 w 533400"/>
+                <a:gd name="csY15" fmla="*/ 309563 h 695325"/>
+                <a:gd name="csX16" fmla="*/ 466725 w 533400"/>
+                <a:gd name="csY16" fmla="*/ 200025 h 695325"/>
+                <a:gd name="csX17" fmla="*/ 266700 w 533400"/>
+                <a:gd name="csY17" fmla="*/ 0 h 695325"/>
+                <a:gd name="csX18" fmla="*/ 66675 w 533400"/>
+                <a:gd name="csY18" fmla="*/ 200025 h 695325"/>
+                <a:gd name="csX19" fmla="*/ 66675 w 533400"/>
+                <a:gd name="csY19" fmla="*/ 309563 h 695325"/>
+                <a:gd name="csX20" fmla="*/ 0 w 533400"/>
+                <a:gd name="csY20" fmla="*/ 314325 h 695325"/>
+                <a:gd name="csX21" fmla="*/ 0 w 533400"/>
+                <a:gd name="csY21" fmla="*/ 676275 h 695325"/>
+                <a:gd name="csX22" fmla="*/ 266700 w 533400"/>
+                <a:gd name="csY22" fmla="*/ 695325 h 695325"/>
+                <a:gd name="csX23" fmla="*/ 533400 w 533400"/>
+                <a:gd name="csY23" fmla="*/ 676275 h 695325"/>
+                <a:gd name="csX24" fmla="*/ 533400 w 533400"/>
+                <a:gd name="csY24" fmla="*/ 314325 h 695325"/>
+                <a:gd name="csX25" fmla="*/ 466725 w 533400"/>
+                <a:gd name="csY25" fmla="*/ 309563 h 695325"/>
+              </a:gdLst>
+              <a:ahLst/>
+              <a:cxnLst>
+                <a:cxn ang="0">
+                  <a:pos x="csX0" y="csY0"/>
+                </a:cxn>
+                <a:cxn ang="0">
+                  <a:pos x="csX1" y="csY1"/>
+                </a:cxn>
+                <a:cxn ang="0">
+                  <a:pos x="csX2" y="csY2"/>
+                </a:cxn>
+                <a:cxn ang="0">
+                  <a:pos x="csX3" y="csY3"/>
+                </a:cxn>
+                <a:cxn ang="0">
+                  <a:pos x="csX4" y="csY4"/>
+                </a:cxn>
+                <a:cxn ang="0">
+                  <a:pos x="csX5" y="csY5"/>
+                </a:cxn>
+                <a:cxn ang="0">
+                  <a:pos x="csX6" y="csY6"/>
+                </a:cxn>
+                <a:cxn ang="0">
+                  <a:pos x="csX7" y="csY7"/>
+                </a:cxn>
+                <a:cxn ang="0">
+                  <a:pos x="csX8" y="csY8"/>
+                </a:cxn>
+                <a:cxn ang="0">
+                  <a:pos x="csX9" y="csY9"/>
+                </a:cxn>
+                <a:cxn ang="0">
+                  <a:pos x="csX10" y="csY10"/>
+                </a:cxn>
+                <a:cxn ang="0">
+                  <a:pos x="csX11" y="csY11"/>
+                </a:cxn>
+                <a:cxn ang="0">
+                  <a:pos x="csX12" y="csY12"/>
+                </a:cxn>
+                <a:cxn ang="0">
+                  <a:pos x="csX13" y="csY13"/>
+                </a:cxn>
+                <a:cxn ang="0">
+                  <a:pos x="csX14" y="csY14"/>
+                </a:cxn>
+                <a:cxn ang="0">
+                  <a:pos x="csX15" y="csY15"/>
+                </a:cxn>
+                <a:cxn ang="0">
+                  <a:pos x="csX16" y="csY16"/>
+                </a:cxn>
+                <a:cxn ang="0">
+                  <a:pos x="csX17" y="csY17"/>
+                </a:cxn>
+                <a:cxn ang="0">
+                  <a:pos x="csX18" y="csY18"/>
+                </a:cxn>
+                <a:cxn ang="0">
+                  <a:pos x="csX19" y="csY19"/>
+                </a:cxn>
+                <a:cxn ang="0">
+                  <a:pos x="csX20" y="csY20"/>
+                </a:cxn>
+                <a:cxn ang="0">
+                  <a:pos x="csX21" y="csY21"/>
+                </a:cxn>
+                <a:cxn ang="0">
+                  <a:pos x="csX22" y="csY22"/>
+                </a:cxn>
+                <a:cxn ang="0">
+                  <a:pos x="csX23" y="csY23"/>
+                </a:cxn>
+                <a:cxn ang="0">
+                  <a:pos x="csX24" y="csY24"/>
+                </a:cxn>
+                <a:cxn ang="0">
+                  <a:pos x="csX25" y="csY25"/>
+                </a:cxn>
+              </a:cxnLst>
+              <a:rect l="l" t="t" r="r" b="b"/>
+              <a:pathLst>
+                <a:path w="533400" h="695325">
+                  <a:moveTo>
+                    <a:pt x="285750" y="549593"/>
+                  </a:moveTo>
+                  <a:lnTo>
+                    <a:pt x="285750" y="600075"/>
+                  </a:lnTo>
+                  <a:lnTo>
+                    <a:pt x="247650" y="600075"/>
+                  </a:lnTo>
+                  <a:lnTo>
+                    <a:pt x="247650" y="549593"/>
+                  </a:lnTo>
+                  <a:cubicBezTo>
+                    <a:pt x="225743" y="541973"/>
+                    <a:pt x="209550" y="521017"/>
+                    <a:pt x="209550" y="495300"/>
+                  </a:cubicBezTo>
+                  <a:cubicBezTo>
+                    <a:pt x="209550" y="463868"/>
+                    <a:pt x="235268" y="438150"/>
+                    <a:pt x="266700" y="438150"/>
+                  </a:cubicBezTo>
+                  <a:cubicBezTo>
+                    <a:pt x="298133" y="438150"/>
+                    <a:pt x="323850" y="463868"/>
+                    <a:pt x="323850" y="495300"/>
+                  </a:cubicBezTo>
+                  <a:cubicBezTo>
+                    <a:pt x="323850" y="520065"/>
+                    <a:pt x="307658" y="541020"/>
+                    <a:pt x="285750" y="549593"/>
+                  </a:cubicBezTo>
+                  <a:close/>
+                  <a:moveTo>
+                    <a:pt x="123825" y="200025"/>
+                  </a:moveTo>
+                  <a:cubicBezTo>
+                    <a:pt x="123825" y="120968"/>
+                    <a:pt x="187643" y="57150"/>
+                    <a:pt x="266700" y="57150"/>
+                  </a:cubicBezTo>
+                  <a:cubicBezTo>
+                    <a:pt x="345758" y="57150"/>
+                    <a:pt x="409575" y="120968"/>
+                    <a:pt x="409575" y="200025"/>
+                  </a:cubicBezTo>
+                  <a:lnTo>
+                    <a:pt x="409575" y="305753"/>
+                  </a:lnTo>
+                  <a:lnTo>
+                    <a:pt x="266700" y="295275"/>
+                  </a:lnTo>
+                  <a:lnTo>
+                    <a:pt x="123825" y="305753"/>
+                  </a:lnTo>
+                  <a:lnTo>
+                    <a:pt x="123825" y="200025"/>
+                  </a:lnTo>
+                  <a:close/>
+                  <a:moveTo>
+                    <a:pt x="466725" y="309563"/>
+                  </a:moveTo>
+                  <a:lnTo>
+                    <a:pt x="466725" y="200025"/>
+                  </a:lnTo>
+                  <a:cubicBezTo>
+                    <a:pt x="466725" y="89535"/>
+                    <a:pt x="377190" y="0"/>
+                    <a:pt x="266700" y="0"/>
+                  </a:cubicBezTo>
+                  <a:cubicBezTo>
+                    <a:pt x="156210" y="0"/>
+                    <a:pt x="66675" y="89535"/>
+                    <a:pt x="66675" y="200025"/>
+                  </a:cubicBezTo>
+                  <a:lnTo>
+                    <a:pt x="66675" y="309563"/>
+                  </a:lnTo>
+                  <a:lnTo>
+                    <a:pt x="0" y="314325"/>
+                  </a:lnTo>
+                  <a:lnTo>
+                    <a:pt x="0" y="676275"/>
+                  </a:lnTo>
+                  <a:lnTo>
+                    <a:pt x="266700" y="695325"/>
+                  </a:lnTo>
+                  <a:lnTo>
+                    <a:pt x="533400" y="676275"/>
+                  </a:lnTo>
+                  <a:lnTo>
+                    <a:pt x="533400" y="314325"/>
+                  </a:lnTo>
+                  <a:lnTo>
+                    <a:pt x="466725" y="309563"/>
+                  </a:lnTo>
+                  <a:close/>
+                </a:path>
+              </a:pathLst>
+            </a:custGeom>
+            <a:solidFill>
+              <a:srgbClr val="CCCCCC"/>
+            </a:solidFill>
+            <a:ln w="9525" cap="flat">
+              <a:noFill/>
+              <a:prstDash val="solid"/>
+              <a:miter/>
+            </a:ln>
+          </p:spPr>
+          <p:txBody>
+            <a:bodyPr/>
+            <a:lstStyle/>
+            <a:p>
+              <a:endParaRPr lang="fr-CA"/>
+            </a:p>
+          </p:txBody>
+        </p:sp>
+        <p:sp>
+          <p:nvSpPr>
+            <p:cNvPr id="39" name="Rectangle 38">
+              <a:extLst>
+                <a:ext uri="{FF2B5EF4-FFF2-40B4-BE49-F238E27FC236}">
+                  <a16:creationId xmlns:a16="http://schemas.microsoft.com/office/drawing/2014/main" id="{5EFB7B8E-5BA1-39B3-ADF6-1C6E121518EC}"/>
+                </a:ext>
+              </a:extLst>
+            </p:cNvPr>
+            <p:cNvSpPr/>
+            <p:nvPr/>
+          </p:nvSpPr>
+          <p:spPr>
+            <a:xfrm>
+              <a:off x="4738785" y="2982771"/>
+              <a:ext cx="2506202" cy="36000"/>
+            </a:xfrm>
+            <a:prstGeom prst="rect">
+              <a:avLst/>
+            </a:prstGeom>
+            <a:solidFill>
+              <a:srgbClr val="999999"/>
+            </a:solidFill>
+            <a:ln>
+              <a:noFill/>
+            </a:ln>
+          </p:spPr>
+          <p:style>
+            <a:lnRef idx="2">
+              <a:schemeClr val="accent1">
+                <a:shade val="15000"/>
+              </a:schemeClr>
+            </a:lnRef>
+            <a:fillRef idx="1">
+              <a:schemeClr val="accent1"/>
+            </a:fillRef>
+            <a:effectRef idx="0">
+              <a:schemeClr val="accent1"/>
+            </a:effectRef>
+            <a:fontRef idx="minor">
+              <a:schemeClr val="lt1"/>
+            </a:fontRef>
+          </p:style>
+          <p:txBody>
+            <a:bodyPr rtlCol="0" anchor="ctr"/>
+            <a:lstStyle/>
+            <a:p>
+              <a:pPr algn="ctr"/>
+              <a:endParaRPr lang="fr-CA"/>
+            </a:p>
+          </p:txBody>
+        </p:sp>
+        <p:sp>
+          <p:nvSpPr>
+            <p:cNvPr id="40" name="Rectangle 39">
+              <a:extLst>
+                <a:ext uri="{FF2B5EF4-FFF2-40B4-BE49-F238E27FC236}">
+                  <a16:creationId xmlns:a16="http://schemas.microsoft.com/office/drawing/2014/main" id="{1C642BA4-9B7E-DE52-50E9-F2D82D3BD3D6}"/>
+                </a:ext>
+              </a:extLst>
+            </p:cNvPr>
+            <p:cNvSpPr/>
+            <p:nvPr/>
+          </p:nvSpPr>
+          <p:spPr>
+            <a:xfrm>
+              <a:off x="4738785" y="3292458"/>
+              <a:ext cx="2506202" cy="36000"/>
+            </a:xfrm>
+            <a:prstGeom prst="rect">
+              <a:avLst/>
+            </a:prstGeom>
+            <a:solidFill>
+              <a:srgbClr val="999999"/>
+            </a:solidFill>
+            <a:ln>
+              <a:noFill/>
+            </a:ln>
+          </p:spPr>
+          <p:style>
+            <a:lnRef idx="2">
+              <a:schemeClr val="accent1">
+                <a:shade val="15000"/>
+              </a:schemeClr>
+            </a:lnRef>
+            <a:fillRef idx="1">
+              <a:schemeClr val="accent1"/>
+            </a:fillRef>
+            <a:effectRef idx="0">
+              <a:schemeClr val="accent1"/>
+            </a:effectRef>
+            <a:fontRef idx="minor">
+              <a:schemeClr val="lt1"/>
+            </a:fontRef>
+          </p:style>
+          <p:txBody>
+            <a:bodyPr rtlCol="0" anchor="ctr"/>
+            <a:lstStyle/>
+            <a:p>
+              <a:pPr algn="ctr"/>
+              <a:endParaRPr lang="fr-CA"/>
+            </a:p>
+          </p:txBody>
+        </p:sp>
+        <p:sp>
+          <p:nvSpPr>
+            <p:cNvPr id="41" name="Rectangle 40">
+              <a:extLst>
+                <a:ext uri="{FF2B5EF4-FFF2-40B4-BE49-F238E27FC236}">
+                  <a16:creationId xmlns:a16="http://schemas.microsoft.com/office/drawing/2014/main" id="{24B35E88-C14E-B687-3ED1-C18AE914BF74}"/>
+                </a:ext>
+              </a:extLst>
+            </p:cNvPr>
+            <p:cNvSpPr/>
+            <p:nvPr/>
+          </p:nvSpPr>
+          <p:spPr>
+            <a:xfrm>
+              <a:off x="4738785" y="4838668"/>
+              <a:ext cx="2506202" cy="36000"/>
+            </a:xfrm>
+            <a:prstGeom prst="rect">
+              <a:avLst/>
+            </a:prstGeom>
+            <a:solidFill>
+              <a:srgbClr val="999999"/>
+            </a:solidFill>
+            <a:ln>
+              <a:noFill/>
+            </a:ln>
+          </p:spPr>
+          <p:style>
+            <a:lnRef idx="2">
+              <a:schemeClr val="accent1">
+                <a:shade val="15000"/>
+              </a:schemeClr>
+            </a:lnRef>
+            <a:fillRef idx="1">
+              <a:schemeClr val="accent1"/>
+            </a:fillRef>
+            <a:effectRef idx="0">
+              <a:schemeClr val="accent1"/>
+            </a:effectRef>
+            <a:fontRef idx="minor">
+              <a:schemeClr val="lt1"/>
+            </a:fontRef>
+          </p:style>
+          <p:txBody>
+            <a:bodyPr rtlCol="0" anchor="ctr"/>
+            <a:lstStyle/>
+            <a:p>
+              <a:pPr algn="ctr"/>
+              <a:endParaRPr lang="fr-CA"/>
+            </a:p>
+          </p:txBody>
+        </p:sp>
+        <p:sp>
+          <p:nvSpPr>
+            <p:cNvPr id="42" name="Rectangle 41">
+              <a:extLst>
+                <a:ext uri="{FF2B5EF4-FFF2-40B4-BE49-F238E27FC236}">
+                  <a16:creationId xmlns:a16="http://schemas.microsoft.com/office/drawing/2014/main" id="{C088647A-A711-A0FB-8982-346A2DDE1328}"/>
+                </a:ext>
+              </a:extLst>
+            </p:cNvPr>
+            <p:cNvSpPr/>
+            <p:nvPr/>
+          </p:nvSpPr>
+          <p:spPr>
+            <a:xfrm>
+              <a:off x="4738785" y="3602146"/>
+              <a:ext cx="2506202" cy="36000"/>
+            </a:xfrm>
+            <a:prstGeom prst="rect">
+              <a:avLst/>
+            </a:prstGeom>
+            <a:solidFill>
+              <a:srgbClr val="999999"/>
+            </a:solidFill>
+            <a:ln>
+              <a:noFill/>
+            </a:ln>
+          </p:spPr>
+          <p:style>
+            <a:lnRef idx="2">
+              <a:schemeClr val="accent1">
+                <a:shade val="15000"/>
+              </a:schemeClr>
+            </a:lnRef>
+            <a:fillRef idx="1">
+              <a:schemeClr val="accent1"/>
+            </a:fillRef>
+            <a:effectRef idx="0">
+              <a:schemeClr val="accent1"/>
+            </a:effectRef>
+            <a:fontRef idx="minor">
+              <a:schemeClr val="lt1"/>
+            </a:fontRef>
+          </p:style>
+          <p:txBody>
+            <a:bodyPr rtlCol="0" anchor="ctr"/>
+            <a:lstStyle/>
+            <a:p>
+              <a:pPr algn="ctr"/>
+              <a:endParaRPr lang="fr-CA"/>
+            </a:p>
+          </p:txBody>
+        </p:sp>
+        <p:sp>
+          <p:nvSpPr>
+            <p:cNvPr id="43" name="Oval 42">
+              <a:extLst>
+                <a:ext uri="{FF2B5EF4-FFF2-40B4-BE49-F238E27FC236}">
+                  <a16:creationId xmlns:a16="http://schemas.microsoft.com/office/drawing/2014/main" id="{9E42FD7D-AD45-A441-ACFB-4D8B0159775F}"/>
+                </a:ext>
+              </a:extLst>
+            </p:cNvPr>
+            <p:cNvSpPr/>
+            <p:nvPr/>
+          </p:nvSpPr>
+          <p:spPr>
+            <a:xfrm>
+              <a:off x="7968600" y="1794206"/>
+              <a:ext cx="900000" cy="900000"/>
+            </a:xfrm>
+            <a:prstGeom prst="ellipse">
+              <a:avLst/>
+            </a:prstGeom>
+            <a:solidFill>
+              <a:srgbClr val="CCCCCC"/>
+            </a:solidFill>
+            <a:ln>
+              <a:noFill/>
+            </a:ln>
+          </p:spPr>
+          <p:style>
+            <a:lnRef idx="2">
+              <a:schemeClr val="accent1">
+                <a:shade val="15000"/>
+              </a:schemeClr>
+            </a:lnRef>
+            <a:fillRef idx="1">
+              <a:schemeClr val="accent1"/>
+            </a:fillRef>
+            <a:effectRef idx="0">
+              <a:schemeClr val="accent1"/>
+            </a:effectRef>
+            <a:fontRef idx="minor">
+              <a:schemeClr val="lt1"/>
+            </a:fontRef>
+          </p:style>
+          <p:txBody>
+            <a:bodyPr rtlCol="0" anchor="ctr"/>
+            <a:lstStyle/>
+            <a:p>
+              <a:pPr algn="ctr"/>
+              <a:endParaRPr lang="fr-CA"/>
+            </a:p>
+          </p:txBody>
+        </p:sp>
+        <p:sp>
+          <p:nvSpPr>
+            <p:cNvPr id="44" name="Oval 43">
+              <a:extLst>
+                <a:ext uri="{FF2B5EF4-FFF2-40B4-BE49-F238E27FC236}">
+                  <a16:creationId xmlns:a16="http://schemas.microsoft.com/office/drawing/2014/main" id="{8B7DC458-6DB1-7677-E96E-D692A1AAF244}"/>
+                </a:ext>
+              </a:extLst>
+            </p:cNvPr>
+            <p:cNvSpPr/>
+            <p:nvPr/>
+          </p:nvSpPr>
+          <p:spPr>
+            <a:xfrm>
+              <a:off x="7968600" y="3057103"/>
+              <a:ext cx="900000" cy="900000"/>
             </a:xfrm>
             <a:prstGeom prst="ellipse">
               <a:avLst/>
@@ -10114,879 +12959,214 @@
             </a:p>
           </p:txBody>
         </p:sp>
-        <p:grpSp>
-          <p:nvGrpSpPr>
-            <p:cNvPr id="45" name="Group 44">
+        <p:sp>
+          <p:nvSpPr>
+            <p:cNvPr id="48" name="Oval 47">
               <a:extLst>
                 <a:ext uri="{FF2B5EF4-FFF2-40B4-BE49-F238E27FC236}">
-                  <a16:creationId xmlns:a16="http://schemas.microsoft.com/office/drawing/2014/main" id="{5744F132-23F5-0A22-9BD2-546615F28F91}"/>
+                  <a16:creationId xmlns:a16="http://schemas.microsoft.com/office/drawing/2014/main" id="{1B2511C8-7422-0589-62DB-1852899FB6B3}"/>
                 </a:ext>
               </a:extLst>
             </p:cNvPr>
-            <p:cNvGrpSpPr/>
+            <p:cNvSpPr/>
             <p:nvPr/>
-          </p:nvGrpSpPr>
-          <p:grpSpPr>
+          </p:nvSpPr>
+          <p:spPr>
             <a:xfrm>
-              <a:off x="5183005" y="451610"/>
-              <a:ext cx="2151245" cy="3592076"/>
-              <a:chOff x="5183005" y="451610"/>
-              <a:chExt cx="2151245" cy="3592076"/>
+              <a:off x="7968600" y="4320000"/>
+              <a:ext cx="900000" cy="900000"/>
             </a:xfrm>
-          </p:grpSpPr>
-          <p:sp>
-            <p:nvSpPr>
-              <p:cNvPr id="70" name="Freeform: Shape 69">
-                <a:extLst>
-                  <a:ext uri="{FF2B5EF4-FFF2-40B4-BE49-F238E27FC236}">
-                    <a16:creationId xmlns:a16="http://schemas.microsoft.com/office/drawing/2014/main" id="{E941FF87-D3F7-0541-04C2-720F5DDF54EC}"/>
-                  </a:ext>
-                </a:extLst>
-              </p:cNvPr>
-              <p:cNvSpPr/>
-              <p:nvPr/>
-            </p:nvSpPr>
-            <p:spPr>
-              <a:xfrm>
-                <a:off x="5189006" y="451610"/>
-                <a:ext cx="1848676" cy="380337"/>
-              </a:xfrm>
-              <a:custGeom>
-                <a:avLst/>
-                <a:gdLst>
-                  <a:gd name="csX0" fmla="*/ 28575 w 361949"/>
-                  <a:gd name="csY0" fmla="*/ 85725 h 85725"/>
-                  <a:gd name="csX1" fmla="*/ 333375 w 361949"/>
-                  <a:gd name="csY1" fmla="*/ 85725 h 85725"/>
-                  <a:gd name="csX2" fmla="*/ 361950 w 361949"/>
-                  <a:gd name="csY2" fmla="*/ 57150 h 85725"/>
-                  <a:gd name="csX3" fmla="*/ 333375 w 361949"/>
-                  <a:gd name="csY3" fmla="*/ 28575 h 85725"/>
-                  <a:gd name="csX4" fmla="*/ 242888 w 361949"/>
-                  <a:gd name="csY4" fmla="*/ 28575 h 85725"/>
-                  <a:gd name="csX5" fmla="*/ 233867 w 361949"/>
-                  <a:gd name="csY5" fmla="*/ 10535 h 85725"/>
-                  <a:gd name="csX6" fmla="*/ 216827 w 361949"/>
-                  <a:gd name="csY6" fmla="*/ 0 h 85725"/>
-                  <a:gd name="csX7" fmla="*/ 145123 w 361949"/>
-                  <a:gd name="csY7" fmla="*/ 0 h 85725"/>
-                  <a:gd name="csX8" fmla="*/ 128083 w 361949"/>
-                  <a:gd name="csY8" fmla="*/ 10535 h 85725"/>
-                  <a:gd name="csX9" fmla="*/ 119063 w 361949"/>
-                  <a:gd name="csY9" fmla="*/ 28575 h 85725"/>
-                  <a:gd name="csX10" fmla="*/ 28575 w 361949"/>
-                  <a:gd name="csY10" fmla="*/ 28575 h 85725"/>
-                  <a:gd name="csX11" fmla="*/ 0 w 361949"/>
-                  <a:gd name="csY11" fmla="*/ 57150 h 85725"/>
-                  <a:gd name="csX12" fmla="*/ 28575 w 361949"/>
-                  <a:gd name="csY12" fmla="*/ 85725 h 85725"/>
-                </a:gdLst>
-                <a:ahLst/>
-                <a:cxnLst>
-                  <a:cxn ang="0">
-                    <a:pos x="csX0" y="csY0"/>
-                  </a:cxn>
-                  <a:cxn ang="0">
-                    <a:pos x="csX1" y="csY1"/>
-                  </a:cxn>
-                  <a:cxn ang="0">
-                    <a:pos x="csX2" y="csY2"/>
-                  </a:cxn>
-                  <a:cxn ang="0">
-                    <a:pos x="csX3" y="csY3"/>
-                  </a:cxn>
-                  <a:cxn ang="0">
-                    <a:pos x="csX4" y="csY4"/>
-                  </a:cxn>
-                  <a:cxn ang="0">
-                    <a:pos x="csX5" y="csY5"/>
-                  </a:cxn>
-                  <a:cxn ang="0">
-                    <a:pos x="csX6" y="csY6"/>
-                  </a:cxn>
-                  <a:cxn ang="0">
-                    <a:pos x="csX7" y="csY7"/>
-                  </a:cxn>
-                  <a:cxn ang="0">
-                    <a:pos x="csX8" y="csY8"/>
-                  </a:cxn>
-                  <a:cxn ang="0">
-                    <a:pos x="csX9" y="csY9"/>
-                  </a:cxn>
-                  <a:cxn ang="0">
-                    <a:pos x="csX10" y="csY10"/>
-                  </a:cxn>
-                  <a:cxn ang="0">
-                    <a:pos x="csX11" y="csY11"/>
-                  </a:cxn>
-                  <a:cxn ang="0">
-                    <a:pos x="csX12" y="csY12"/>
-                  </a:cxn>
-                </a:cxnLst>
-                <a:rect l="l" t="t" r="r" b="b"/>
-                <a:pathLst>
-                  <a:path w="361949" h="85725">
-                    <a:moveTo>
-                      <a:pt x="28575" y="85725"/>
-                    </a:moveTo>
-                    <a:lnTo>
-                      <a:pt x="333375" y="85725"/>
-                    </a:lnTo>
-                    <a:cubicBezTo>
-                      <a:pt x="349156" y="85725"/>
-                      <a:pt x="361950" y="72932"/>
-                      <a:pt x="361950" y="57150"/>
-                    </a:cubicBezTo>
-                    <a:cubicBezTo>
-                      <a:pt x="361950" y="41369"/>
-                      <a:pt x="349156" y="28575"/>
-                      <a:pt x="333375" y="28575"/>
-                    </a:cubicBezTo>
-                    <a:lnTo>
-                      <a:pt x="242888" y="28575"/>
-                    </a:lnTo>
-                    <a:lnTo>
-                      <a:pt x="233867" y="10535"/>
-                    </a:lnTo>
-                    <a:cubicBezTo>
-                      <a:pt x="230641" y="4079"/>
-                      <a:pt x="224044" y="0"/>
-                      <a:pt x="216827" y="0"/>
-                    </a:cubicBezTo>
-                    <a:lnTo>
-                      <a:pt x="145123" y="0"/>
-                    </a:lnTo>
-                    <a:cubicBezTo>
-                      <a:pt x="137906" y="0"/>
-                      <a:pt x="131309" y="4079"/>
-                      <a:pt x="128083" y="10535"/>
-                    </a:cubicBezTo>
-                    <a:lnTo>
-                      <a:pt x="119063" y="28575"/>
-                    </a:lnTo>
-                    <a:lnTo>
-                      <a:pt x="28575" y="28575"/>
-                    </a:lnTo>
-                    <a:cubicBezTo>
-                      <a:pt x="12793" y="28575"/>
-                      <a:pt x="0" y="41369"/>
-                      <a:pt x="0" y="57150"/>
-                    </a:cubicBezTo>
-                    <a:cubicBezTo>
-                      <a:pt x="0" y="72932"/>
-                      <a:pt x="12793" y="85725"/>
-                      <a:pt x="28575" y="85725"/>
-                    </a:cubicBezTo>
-                    <a:close/>
-                  </a:path>
-                </a:pathLst>
-              </a:custGeom>
-              <a:solidFill>
-                <a:srgbClr val="333333"/>
-              </a:solidFill>
-              <a:ln w="9525" cap="flat">
-                <a:noFill/>
-                <a:prstDash val="solid"/>
-                <a:miter/>
-              </a:ln>
-            </p:spPr>
-            <p:txBody>
-              <a:bodyPr/>
-              <a:lstStyle/>
-              <a:p>
-                <a:endParaRPr lang="fr-CA"/>
-              </a:p>
-            </p:txBody>
-          </p:sp>
-          <p:sp>
-            <p:nvSpPr>
-              <p:cNvPr id="71" name="Freeform: Shape 70">
-                <a:extLst>
-                  <a:ext uri="{FF2B5EF4-FFF2-40B4-BE49-F238E27FC236}">
-                    <a16:creationId xmlns:a16="http://schemas.microsoft.com/office/drawing/2014/main" id="{639804AD-C66C-5F6C-40B6-F36420C7B2EF}"/>
-                  </a:ext>
-                </a:extLst>
-              </p:cNvPr>
-              <p:cNvSpPr/>
-              <p:nvPr/>
-            </p:nvSpPr>
-            <p:spPr>
-              <a:xfrm>
-                <a:off x="5273570" y="1000986"/>
-                <a:ext cx="2060680" cy="1394571"/>
-              </a:xfrm>
-              <a:custGeom>
-                <a:avLst/>
-                <a:gdLst>
-                  <a:gd name="csX0" fmla="*/ 365322 w 403457"/>
-                  <a:gd name="csY0" fmla="*/ 47625 h 314325"/>
-                  <a:gd name="csX1" fmla="*/ 318078 w 403457"/>
-                  <a:gd name="csY1" fmla="*/ 47625 h 314325"/>
-                  <a:gd name="csX2" fmla="*/ 323850 w 403457"/>
-                  <a:gd name="csY2" fmla="*/ 0 h 314325"/>
-                  <a:gd name="csX3" fmla="*/ 0 w 403457"/>
-                  <a:gd name="csY3" fmla="*/ 0 h 314325"/>
-                  <a:gd name="csX4" fmla="*/ 38100 w 403457"/>
-                  <a:gd name="csY4" fmla="*/ 314325 h 314325"/>
-                  <a:gd name="csX5" fmla="*/ 285750 w 403457"/>
-                  <a:gd name="csY5" fmla="*/ 314325 h 314325"/>
-                  <a:gd name="csX6" fmla="*/ 293570 w 403457"/>
-                  <a:gd name="csY6" fmla="*/ 249784 h 314325"/>
-                  <a:gd name="csX7" fmla="*/ 352625 w 403457"/>
-                  <a:gd name="csY7" fmla="*/ 241906 h 314325"/>
-                  <a:gd name="csX8" fmla="*/ 385267 w 403457"/>
-                  <a:gd name="csY8" fmla="*/ 209798 h 314325"/>
-                  <a:gd name="csX9" fmla="*/ 403031 w 403457"/>
-                  <a:gd name="csY9" fmla="*/ 91373 h 314325"/>
-                  <a:gd name="csX10" fmla="*/ 371001 w 403457"/>
-                  <a:gd name="csY10" fmla="*/ 48046 h 314325"/>
-                  <a:gd name="csX11" fmla="*/ 365322 w 403457"/>
-                  <a:gd name="csY11" fmla="*/ 47625 h 314325"/>
-                  <a:gd name="csX12" fmla="*/ 347605 w 403457"/>
-                  <a:gd name="csY12" fmla="*/ 204140 h 314325"/>
-                  <a:gd name="csX13" fmla="*/ 298352 w 403457"/>
-                  <a:gd name="csY13" fmla="*/ 210712 h 314325"/>
-                  <a:gd name="csX14" fmla="*/ 313449 w 403457"/>
-                  <a:gd name="csY14" fmla="*/ 85725 h 314325"/>
-                  <a:gd name="csX15" fmla="*/ 365322 w 403457"/>
-                  <a:gd name="csY15" fmla="*/ 85725 h 314325"/>
-                </a:gdLst>
-                <a:ahLst/>
-                <a:cxnLst>
-                  <a:cxn ang="0">
-                    <a:pos x="csX0" y="csY0"/>
-                  </a:cxn>
-                  <a:cxn ang="0">
-                    <a:pos x="csX1" y="csY1"/>
-                  </a:cxn>
-                  <a:cxn ang="0">
-                    <a:pos x="csX2" y="csY2"/>
-                  </a:cxn>
-                  <a:cxn ang="0">
-                    <a:pos x="csX3" y="csY3"/>
-                  </a:cxn>
-                  <a:cxn ang="0">
-                    <a:pos x="csX4" y="csY4"/>
-                  </a:cxn>
-                  <a:cxn ang="0">
-                    <a:pos x="csX5" y="csY5"/>
-                  </a:cxn>
-                  <a:cxn ang="0">
-                    <a:pos x="csX6" y="csY6"/>
-                  </a:cxn>
-                  <a:cxn ang="0">
-                    <a:pos x="csX7" y="csY7"/>
-                  </a:cxn>
-                  <a:cxn ang="0">
-                    <a:pos x="csX8" y="csY8"/>
-                  </a:cxn>
-                  <a:cxn ang="0">
-                    <a:pos x="csX9" y="csY9"/>
-                  </a:cxn>
-                  <a:cxn ang="0">
-                    <a:pos x="csX10" y="csY10"/>
-                  </a:cxn>
-                  <a:cxn ang="0">
-                    <a:pos x="csX11" y="csY11"/>
-                  </a:cxn>
-                  <a:cxn ang="0">
-                    <a:pos x="csX12" y="csY12"/>
-                  </a:cxn>
-                  <a:cxn ang="0">
-                    <a:pos x="csX13" y="csY13"/>
-                  </a:cxn>
-                  <a:cxn ang="0">
-                    <a:pos x="csX14" y="csY14"/>
-                  </a:cxn>
-                  <a:cxn ang="0">
-                    <a:pos x="csX15" y="csY15"/>
-                  </a:cxn>
-                </a:cxnLst>
-                <a:rect l="l" t="t" r="r" b="b"/>
-                <a:pathLst>
-                  <a:path w="403457" h="314325">
-                    <a:moveTo>
-                      <a:pt x="365322" y="47625"/>
-                    </a:moveTo>
-                    <a:lnTo>
-                      <a:pt x="318078" y="47625"/>
-                    </a:lnTo>
-                    <a:lnTo>
-                      <a:pt x="323850" y="0"/>
-                    </a:lnTo>
-                    <a:lnTo>
-                      <a:pt x="0" y="0"/>
-                    </a:lnTo>
-                    <a:lnTo>
-                      <a:pt x="38100" y="314325"/>
-                    </a:lnTo>
-                    <a:lnTo>
-                      <a:pt x="285750" y="314325"/>
-                    </a:lnTo>
-                    <a:lnTo>
-                      <a:pt x="293570" y="249784"/>
-                    </a:lnTo>
-                    <a:lnTo>
-                      <a:pt x="352625" y="241906"/>
-                    </a:lnTo>
-                    <a:cubicBezTo>
-                      <a:pt x="369440" y="239664"/>
-                      <a:pt x="382749" y="226574"/>
-                      <a:pt x="385267" y="209798"/>
-                    </a:cubicBezTo>
-                    <a:lnTo>
-                      <a:pt x="403031" y="91373"/>
-                    </a:lnTo>
-                    <a:cubicBezTo>
-                      <a:pt x="406151" y="70564"/>
-                      <a:pt x="391810" y="51165"/>
-                      <a:pt x="371001" y="48046"/>
-                    </a:cubicBezTo>
-                    <a:cubicBezTo>
-                      <a:pt x="369121" y="47764"/>
-                      <a:pt x="367223" y="47623"/>
-                      <a:pt x="365322" y="47625"/>
-                    </a:cubicBezTo>
-                    <a:close/>
-                    <a:moveTo>
-                      <a:pt x="347605" y="204140"/>
-                    </a:moveTo>
-                    <a:lnTo>
-                      <a:pt x="298352" y="210712"/>
-                    </a:lnTo>
-                    <a:lnTo>
-                      <a:pt x="313449" y="85725"/>
-                    </a:lnTo>
-                    <a:lnTo>
-                      <a:pt x="365322" y="85725"/>
-                    </a:lnTo>
-                    <a:close/>
-                  </a:path>
-                </a:pathLst>
-              </a:custGeom>
-              <a:solidFill>
-                <a:srgbClr val="CCCCCC"/>
-              </a:solidFill>
-              <a:ln w="9525" cap="flat">
-                <a:noFill/>
-                <a:prstDash val="solid"/>
-                <a:miter/>
-              </a:ln>
-            </p:spPr>
-            <p:txBody>
-              <a:bodyPr/>
-              <a:lstStyle/>
-              <a:p>
-                <a:endParaRPr lang="fr-CA"/>
-              </a:p>
-            </p:txBody>
-          </p:sp>
-          <p:sp>
-            <p:nvSpPr>
-              <p:cNvPr id="73" name="Freeform: Shape 72">
-                <a:extLst>
-                  <a:ext uri="{FF2B5EF4-FFF2-40B4-BE49-F238E27FC236}">
-                    <a16:creationId xmlns:a16="http://schemas.microsoft.com/office/drawing/2014/main" id="{0438848E-381A-072F-74F6-E88EB80B2896}"/>
-                  </a:ext>
-                </a:extLst>
-              </p:cNvPr>
-              <p:cNvSpPr/>
-              <p:nvPr/>
-            </p:nvSpPr>
-            <p:spPr>
-              <a:xfrm>
-                <a:off x="5183005" y="2564596"/>
-                <a:ext cx="1862500" cy="1479090"/>
-              </a:xfrm>
-              <a:custGeom>
-                <a:avLst/>
-                <a:gdLst>
-                  <a:gd name="csX0" fmla="*/ 382353 w 400049"/>
-                  <a:gd name="csY0" fmla="*/ 129854 h 361950"/>
-                  <a:gd name="csX1" fmla="*/ 371923 w 400049"/>
-                  <a:gd name="csY1" fmla="*/ 101594 h 361950"/>
-                  <a:gd name="csX2" fmla="*/ 344024 w 400049"/>
-                  <a:gd name="csY2" fmla="*/ 62541 h 361950"/>
-                  <a:gd name="csX3" fmla="*/ 333375 w 400049"/>
-                  <a:gd name="csY3" fmla="*/ 29318 h 361950"/>
-                  <a:gd name="csX4" fmla="*/ 333375 w 400049"/>
-                  <a:gd name="csY4" fmla="*/ 0 h 361950"/>
-                  <a:gd name="csX5" fmla="*/ 66675 w 400049"/>
-                  <a:gd name="csY5" fmla="*/ 0 h 361950"/>
-                  <a:gd name="csX6" fmla="*/ 66675 w 400049"/>
-                  <a:gd name="csY6" fmla="*/ 29308 h 361950"/>
-                  <a:gd name="csX7" fmla="*/ 56026 w 400049"/>
-                  <a:gd name="csY7" fmla="*/ 62532 h 361950"/>
-                  <a:gd name="csX8" fmla="*/ 28127 w 400049"/>
-                  <a:gd name="csY8" fmla="*/ 101584 h 361950"/>
-                  <a:gd name="csX9" fmla="*/ 17697 w 400049"/>
-                  <a:gd name="csY9" fmla="*/ 129845 h 361950"/>
-                  <a:gd name="csX10" fmla="*/ 0 w 400049"/>
-                  <a:gd name="csY10" fmla="*/ 333375 h 361950"/>
-                  <a:gd name="csX11" fmla="*/ 38100 w 400049"/>
-                  <a:gd name="csY11" fmla="*/ 333375 h 361950"/>
-                  <a:gd name="csX12" fmla="*/ 38100 w 400049"/>
-                  <a:gd name="csY12" fmla="*/ 361950 h 361950"/>
-                  <a:gd name="csX13" fmla="*/ 114300 w 400049"/>
-                  <a:gd name="csY13" fmla="*/ 361950 h 361950"/>
-                  <a:gd name="csX14" fmla="*/ 114300 w 400049"/>
-                  <a:gd name="csY14" fmla="*/ 333375 h 361950"/>
-                  <a:gd name="csX15" fmla="*/ 285750 w 400049"/>
-                  <a:gd name="csY15" fmla="*/ 333375 h 361950"/>
-                  <a:gd name="csX16" fmla="*/ 285750 w 400049"/>
-                  <a:gd name="csY16" fmla="*/ 361950 h 361950"/>
-                  <a:gd name="csX17" fmla="*/ 361950 w 400049"/>
-                  <a:gd name="csY17" fmla="*/ 361950 h 361950"/>
-                  <a:gd name="csX18" fmla="*/ 361950 w 400049"/>
-                  <a:gd name="csY18" fmla="*/ 333375 h 361950"/>
-                  <a:gd name="csX19" fmla="*/ 400050 w 400049"/>
-                  <a:gd name="csY19" fmla="*/ 333375 h 361950"/>
-                  <a:gd name="csX20" fmla="*/ 200025 w 400049"/>
-                  <a:gd name="csY20" fmla="*/ 242888 h 361950"/>
-                  <a:gd name="csX21" fmla="*/ 147638 w 400049"/>
-                  <a:gd name="csY21" fmla="*/ 190500 h 361950"/>
-                  <a:gd name="csX22" fmla="*/ 200025 w 400049"/>
-                  <a:gd name="csY22" fmla="*/ 138113 h 361950"/>
-                  <a:gd name="csX23" fmla="*/ 252413 w 400049"/>
-                  <a:gd name="csY23" fmla="*/ 190500 h 361950"/>
-                  <a:gd name="csX24" fmla="*/ 200025 w 400049"/>
-                  <a:gd name="csY24" fmla="*/ 242888 h 361950"/>
-                  <a:gd name="csX0" fmla="*/ 364656 w 382353"/>
-                  <a:gd name="csY0" fmla="*/ 129854 h 361950"/>
-                  <a:gd name="csX1" fmla="*/ 354226 w 382353"/>
-                  <a:gd name="csY1" fmla="*/ 101594 h 361950"/>
-                  <a:gd name="csX2" fmla="*/ 326327 w 382353"/>
-                  <a:gd name="csY2" fmla="*/ 62541 h 361950"/>
-                  <a:gd name="csX3" fmla="*/ 315678 w 382353"/>
-                  <a:gd name="csY3" fmla="*/ 29318 h 361950"/>
-                  <a:gd name="csX4" fmla="*/ 315678 w 382353"/>
-                  <a:gd name="csY4" fmla="*/ 0 h 361950"/>
-                  <a:gd name="csX5" fmla="*/ 48978 w 382353"/>
-                  <a:gd name="csY5" fmla="*/ 0 h 361950"/>
-                  <a:gd name="csX6" fmla="*/ 48978 w 382353"/>
-                  <a:gd name="csY6" fmla="*/ 29308 h 361950"/>
-                  <a:gd name="csX7" fmla="*/ 38329 w 382353"/>
-                  <a:gd name="csY7" fmla="*/ 62532 h 361950"/>
-                  <a:gd name="csX8" fmla="*/ 10430 w 382353"/>
-                  <a:gd name="csY8" fmla="*/ 101584 h 361950"/>
-                  <a:gd name="csX9" fmla="*/ 0 w 382353"/>
-                  <a:gd name="csY9" fmla="*/ 129845 h 361950"/>
-                  <a:gd name="csX10" fmla="*/ 20403 w 382353"/>
-                  <a:gd name="csY10" fmla="*/ 333375 h 361950"/>
-                  <a:gd name="csX11" fmla="*/ 20403 w 382353"/>
-                  <a:gd name="csY11" fmla="*/ 361950 h 361950"/>
-                  <a:gd name="csX12" fmla="*/ 96603 w 382353"/>
-                  <a:gd name="csY12" fmla="*/ 361950 h 361950"/>
-                  <a:gd name="csX13" fmla="*/ 96603 w 382353"/>
-                  <a:gd name="csY13" fmla="*/ 333375 h 361950"/>
-                  <a:gd name="csX14" fmla="*/ 268053 w 382353"/>
-                  <a:gd name="csY14" fmla="*/ 333375 h 361950"/>
-                  <a:gd name="csX15" fmla="*/ 268053 w 382353"/>
-                  <a:gd name="csY15" fmla="*/ 361950 h 361950"/>
-                  <a:gd name="csX16" fmla="*/ 344253 w 382353"/>
-                  <a:gd name="csY16" fmla="*/ 361950 h 361950"/>
-                  <a:gd name="csX17" fmla="*/ 344253 w 382353"/>
-                  <a:gd name="csY17" fmla="*/ 333375 h 361950"/>
-                  <a:gd name="csX18" fmla="*/ 382353 w 382353"/>
-                  <a:gd name="csY18" fmla="*/ 333375 h 361950"/>
-                  <a:gd name="csX19" fmla="*/ 364656 w 382353"/>
-                  <a:gd name="csY19" fmla="*/ 129854 h 361950"/>
-                  <a:gd name="csX20" fmla="*/ 182328 w 382353"/>
-                  <a:gd name="csY20" fmla="*/ 242888 h 361950"/>
-                  <a:gd name="csX21" fmla="*/ 129941 w 382353"/>
-                  <a:gd name="csY21" fmla="*/ 190500 h 361950"/>
-                  <a:gd name="csX22" fmla="*/ 182328 w 382353"/>
-                  <a:gd name="csY22" fmla="*/ 138113 h 361950"/>
-                  <a:gd name="csX23" fmla="*/ 234716 w 382353"/>
-                  <a:gd name="csY23" fmla="*/ 190500 h 361950"/>
-                  <a:gd name="csX24" fmla="*/ 182328 w 382353"/>
-                  <a:gd name="csY24" fmla="*/ 242888 h 361950"/>
-                  <a:gd name="csX0" fmla="*/ 364656 w 364656"/>
-                  <a:gd name="csY0" fmla="*/ 129854 h 361950"/>
-                  <a:gd name="csX1" fmla="*/ 354226 w 364656"/>
-                  <a:gd name="csY1" fmla="*/ 101594 h 361950"/>
-                  <a:gd name="csX2" fmla="*/ 326327 w 364656"/>
-                  <a:gd name="csY2" fmla="*/ 62541 h 361950"/>
-                  <a:gd name="csX3" fmla="*/ 315678 w 364656"/>
-                  <a:gd name="csY3" fmla="*/ 29318 h 361950"/>
-                  <a:gd name="csX4" fmla="*/ 315678 w 364656"/>
-                  <a:gd name="csY4" fmla="*/ 0 h 361950"/>
-                  <a:gd name="csX5" fmla="*/ 48978 w 364656"/>
-                  <a:gd name="csY5" fmla="*/ 0 h 361950"/>
-                  <a:gd name="csX6" fmla="*/ 48978 w 364656"/>
-                  <a:gd name="csY6" fmla="*/ 29308 h 361950"/>
-                  <a:gd name="csX7" fmla="*/ 38329 w 364656"/>
-                  <a:gd name="csY7" fmla="*/ 62532 h 361950"/>
-                  <a:gd name="csX8" fmla="*/ 10430 w 364656"/>
-                  <a:gd name="csY8" fmla="*/ 101584 h 361950"/>
-                  <a:gd name="csX9" fmla="*/ 0 w 364656"/>
-                  <a:gd name="csY9" fmla="*/ 129845 h 361950"/>
-                  <a:gd name="csX10" fmla="*/ 20403 w 364656"/>
-                  <a:gd name="csY10" fmla="*/ 333375 h 361950"/>
-                  <a:gd name="csX11" fmla="*/ 20403 w 364656"/>
-                  <a:gd name="csY11" fmla="*/ 361950 h 361950"/>
-                  <a:gd name="csX12" fmla="*/ 96603 w 364656"/>
-                  <a:gd name="csY12" fmla="*/ 361950 h 361950"/>
-                  <a:gd name="csX13" fmla="*/ 96603 w 364656"/>
-                  <a:gd name="csY13" fmla="*/ 333375 h 361950"/>
-                  <a:gd name="csX14" fmla="*/ 268053 w 364656"/>
-                  <a:gd name="csY14" fmla="*/ 333375 h 361950"/>
-                  <a:gd name="csX15" fmla="*/ 268053 w 364656"/>
-                  <a:gd name="csY15" fmla="*/ 361950 h 361950"/>
-                  <a:gd name="csX16" fmla="*/ 344253 w 364656"/>
-                  <a:gd name="csY16" fmla="*/ 361950 h 361950"/>
-                  <a:gd name="csX17" fmla="*/ 344253 w 364656"/>
-                  <a:gd name="csY17" fmla="*/ 333375 h 361950"/>
-                  <a:gd name="csX18" fmla="*/ 364656 w 364656"/>
-                  <a:gd name="csY18" fmla="*/ 129854 h 361950"/>
-                  <a:gd name="csX19" fmla="*/ 182328 w 364656"/>
-                  <a:gd name="csY19" fmla="*/ 242888 h 361950"/>
-                  <a:gd name="csX20" fmla="*/ 129941 w 364656"/>
-                  <a:gd name="csY20" fmla="*/ 190500 h 361950"/>
-                  <a:gd name="csX21" fmla="*/ 182328 w 364656"/>
-                  <a:gd name="csY21" fmla="*/ 138113 h 361950"/>
-                  <a:gd name="csX22" fmla="*/ 234716 w 364656"/>
-                  <a:gd name="csY22" fmla="*/ 190500 h 361950"/>
-                  <a:gd name="csX23" fmla="*/ 182328 w 364656"/>
-                  <a:gd name="csY23" fmla="*/ 242888 h 361950"/>
-                  <a:gd name="csX0" fmla="*/ 364656 w 364656"/>
-                  <a:gd name="csY0" fmla="*/ 129854 h 361950"/>
-                  <a:gd name="csX1" fmla="*/ 354226 w 364656"/>
-                  <a:gd name="csY1" fmla="*/ 101594 h 361950"/>
-                  <a:gd name="csX2" fmla="*/ 326327 w 364656"/>
-                  <a:gd name="csY2" fmla="*/ 62541 h 361950"/>
-                  <a:gd name="csX3" fmla="*/ 315678 w 364656"/>
-                  <a:gd name="csY3" fmla="*/ 29318 h 361950"/>
-                  <a:gd name="csX4" fmla="*/ 315678 w 364656"/>
-                  <a:gd name="csY4" fmla="*/ 0 h 361950"/>
-                  <a:gd name="csX5" fmla="*/ 48978 w 364656"/>
-                  <a:gd name="csY5" fmla="*/ 0 h 361950"/>
-                  <a:gd name="csX6" fmla="*/ 48978 w 364656"/>
-                  <a:gd name="csY6" fmla="*/ 29308 h 361950"/>
-                  <a:gd name="csX7" fmla="*/ 38329 w 364656"/>
-                  <a:gd name="csY7" fmla="*/ 62532 h 361950"/>
-                  <a:gd name="csX8" fmla="*/ 10430 w 364656"/>
-                  <a:gd name="csY8" fmla="*/ 101584 h 361950"/>
-                  <a:gd name="csX9" fmla="*/ 0 w 364656"/>
-                  <a:gd name="csY9" fmla="*/ 129845 h 361950"/>
-                  <a:gd name="csX10" fmla="*/ 20403 w 364656"/>
-                  <a:gd name="csY10" fmla="*/ 333375 h 361950"/>
-                  <a:gd name="csX11" fmla="*/ 96603 w 364656"/>
-                  <a:gd name="csY11" fmla="*/ 361950 h 361950"/>
-                  <a:gd name="csX12" fmla="*/ 96603 w 364656"/>
-                  <a:gd name="csY12" fmla="*/ 333375 h 361950"/>
-                  <a:gd name="csX13" fmla="*/ 268053 w 364656"/>
-                  <a:gd name="csY13" fmla="*/ 333375 h 361950"/>
-                  <a:gd name="csX14" fmla="*/ 268053 w 364656"/>
-                  <a:gd name="csY14" fmla="*/ 361950 h 361950"/>
-                  <a:gd name="csX15" fmla="*/ 344253 w 364656"/>
-                  <a:gd name="csY15" fmla="*/ 361950 h 361950"/>
-                  <a:gd name="csX16" fmla="*/ 344253 w 364656"/>
-                  <a:gd name="csY16" fmla="*/ 333375 h 361950"/>
-                  <a:gd name="csX17" fmla="*/ 364656 w 364656"/>
-                  <a:gd name="csY17" fmla="*/ 129854 h 361950"/>
-                  <a:gd name="csX18" fmla="*/ 182328 w 364656"/>
-                  <a:gd name="csY18" fmla="*/ 242888 h 361950"/>
-                  <a:gd name="csX19" fmla="*/ 129941 w 364656"/>
-                  <a:gd name="csY19" fmla="*/ 190500 h 361950"/>
-                  <a:gd name="csX20" fmla="*/ 182328 w 364656"/>
-                  <a:gd name="csY20" fmla="*/ 138113 h 361950"/>
-                  <a:gd name="csX21" fmla="*/ 234716 w 364656"/>
-                  <a:gd name="csY21" fmla="*/ 190500 h 361950"/>
-                  <a:gd name="csX22" fmla="*/ 182328 w 364656"/>
-                  <a:gd name="csY22" fmla="*/ 242888 h 361950"/>
-                  <a:gd name="csX0" fmla="*/ 364656 w 364656"/>
-                  <a:gd name="csY0" fmla="*/ 129854 h 361950"/>
-                  <a:gd name="csX1" fmla="*/ 354226 w 364656"/>
-                  <a:gd name="csY1" fmla="*/ 101594 h 361950"/>
-                  <a:gd name="csX2" fmla="*/ 326327 w 364656"/>
-                  <a:gd name="csY2" fmla="*/ 62541 h 361950"/>
-                  <a:gd name="csX3" fmla="*/ 315678 w 364656"/>
-                  <a:gd name="csY3" fmla="*/ 29318 h 361950"/>
-                  <a:gd name="csX4" fmla="*/ 315678 w 364656"/>
-                  <a:gd name="csY4" fmla="*/ 0 h 361950"/>
-                  <a:gd name="csX5" fmla="*/ 48978 w 364656"/>
-                  <a:gd name="csY5" fmla="*/ 0 h 361950"/>
-                  <a:gd name="csX6" fmla="*/ 48978 w 364656"/>
-                  <a:gd name="csY6" fmla="*/ 29308 h 361950"/>
-                  <a:gd name="csX7" fmla="*/ 38329 w 364656"/>
-                  <a:gd name="csY7" fmla="*/ 62532 h 361950"/>
-                  <a:gd name="csX8" fmla="*/ 10430 w 364656"/>
-                  <a:gd name="csY8" fmla="*/ 101584 h 361950"/>
-                  <a:gd name="csX9" fmla="*/ 0 w 364656"/>
-                  <a:gd name="csY9" fmla="*/ 129845 h 361950"/>
-                  <a:gd name="csX10" fmla="*/ 20403 w 364656"/>
-                  <a:gd name="csY10" fmla="*/ 333375 h 361950"/>
-                  <a:gd name="csX11" fmla="*/ 96603 w 364656"/>
-                  <a:gd name="csY11" fmla="*/ 333375 h 361950"/>
-                  <a:gd name="csX12" fmla="*/ 268053 w 364656"/>
-                  <a:gd name="csY12" fmla="*/ 333375 h 361950"/>
-                  <a:gd name="csX13" fmla="*/ 268053 w 364656"/>
-                  <a:gd name="csY13" fmla="*/ 361950 h 361950"/>
-                  <a:gd name="csX14" fmla="*/ 344253 w 364656"/>
-                  <a:gd name="csY14" fmla="*/ 361950 h 361950"/>
-                  <a:gd name="csX15" fmla="*/ 344253 w 364656"/>
-                  <a:gd name="csY15" fmla="*/ 333375 h 361950"/>
-                  <a:gd name="csX16" fmla="*/ 364656 w 364656"/>
-                  <a:gd name="csY16" fmla="*/ 129854 h 361950"/>
-                  <a:gd name="csX17" fmla="*/ 182328 w 364656"/>
-                  <a:gd name="csY17" fmla="*/ 242888 h 361950"/>
-                  <a:gd name="csX18" fmla="*/ 129941 w 364656"/>
-                  <a:gd name="csY18" fmla="*/ 190500 h 361950"/>
-                  <a:gd name="csX19" fmla="*/ 182328 w 364656"/>
-                  <a:gd name="csY19" fmla="*/ 138113 h 361950"/>
-                  <a:gd name="csX20" fmla="*/ 234716 w 364656"/>
-                  <a:gd name="csY20" fmla="*/ 190500 h 361950"/>
-                  <a:gd name="csX21" fmla="*/ 182328 w 364656"/>
-                  <a:gd name="csY21" fmla="*/ 242888 h 361950"/>
-                  <a:gd name="csX0" fmla="*/ 364656 w 364656"/>
-                  <a:gd name="csY0" fmla="*/ 129854 h 361950"/>
-                  <a:gd name="csX1" fmla="*/ 354226 w 364656"/>
-                  <a:gd name="csY1" fmla="*/ 101594 h 361950"/>
-                  <a:gd name="csX2" fmla="*/ 326327 w 364656"/>
-                  <a:gd name="csY2" fmla="*/ 62541 h 361950"/>
-                  <a:gd name="csX3" fmla="*/ 315678 w 364656"/>
-                  <a:gd name="csY3" fmla="*/ 29318 h 361950"/>
-                  <a:gd name="csX4" fmla="*/ 315678 w 364656"/>
-                  <a:gd name="csY4" fmla="*/ 0 h 361950"/>
-                  <a:gd name="csX5" fmla="*/ 48978 w 364656"/>
-                  <a:gd name="csY5" fmla="*/ 0 h 361950"/>
-                  <a:gd name="csX6" fmla="*/ 48978 w 364656"/>
-                  <a:gd name="csY6" fmla="*/ 29308 h 361950"/>
-                  <a:gd name="csX7" fmla="*/ 38329 w 364656"/>
-                  <a:gd name="csY7" fmla="*/ 62532 h 361950"/>
-                  <a:gd name="csX8" fmla="*/ 10430 w 364656"/>
-                  <a:gd name="csY8" fmla="*/ 101584 h 361950"/>
-                  <a:gd name="csX9" fmla="*/ 0 w 364656"/>
-                  <a:gd name="csY9" fmla="*/ 129845 h 361950"/>
-                  <a:gd name="csX10" fmla="*/ 20403 w 364656"/>
-                  <a:gd name="csY10" fmla="*/ 333375 h 361950"/>
-                  <a:gd name="csX11" fmla="*/ 96603 w 364656"/>
-                  <a:gd name="csY11" fmla="*/ 333375 h 361950"/>
-                  <a:gd name="csX12" fmla="*/ 268053 w 364656"/>
-                  <a:gd name="csY12" fmla="*/ 333375 h 361950"/>
-                  <a:gd name="csX13" fmla="*/ 344253 w 364656"/>
-                  <a:gd name="csY13" fmla="*/ 361950 h 361950"/>
-                  <a:gd name="csX14" fmla="*/ 344253 w 364656"/>
-                  <a:gd name="csY14" fmla="*/ 333375 h 361950"/>
-                  <a:gd name="csX15" fmla="*/ 364656 w 364656"/>
-                  <a:gd name="csY15" fmla="*/ 129854 h 361950"/>
-                  <a:gd name="csX16" fmla="*/ 182328 w 364656"/>
-                  <a:gd name="csY16" fmla="*/ 242888 h 361950"/>
-                  <a:gd name="csX17" fmla="*/ 129941 w 364656"/>
-                  <a:gd name="csY17" fmla="*/ 190500 h 361950"/>
-                  <a:gd name="csX18" fmla="*/ 182328 w 364656"/>
-                  <a:gd name="csY18" fmla="*/ 138113 h 361950"/>
-                  <a:gd name="csX19" fmla="*/ 234716 w 364656"/>
-                  <a:gd name="csY19" fmla="*/ 190500 h 361950"/>
-                  <a:gd name="csX20" fmla="*/ 182328 w 364656"/>
-                  <a:gd name="csY20" fmla="*/ 242888 h 361950"/>
-                  <a:gd name="csX0" fmla="*/ 364656 w 364656"/>
-                  <a:gd name="csY0" fmla="*/ 129854 h 333375"/>
-                  <a:gd name="csX1" fmla="*/ 354226 w 364656"/>
-                  <a:gd name="csY1" fmla="*/ 101594 h 333375"/>
-                  <a:gd name="csX2" fmla="*/ 326327 w 364656"/>
-                  <a:gd name="csY2" fmla="*/ 62541 h 333375"/>
-                  <a:gd name="csX3" fmla="*/ 315678 w 364656"/>
-                  <a:gd name="csY3" fmla="*/ 29318 h 333375"/>
-                  <a:gd name="csX4" fmla="*/ 315678 w 364656"/>
-                  <a:gd name="csY4" fmla="*/ 0 h 333375"/>
-                  <a:gd name="csX5" fmla="*/ 48978 w 364656"/>
-                  <a:gd name="csY5" fmla="*/ 0 h 333375"/>
-                  <a:gd name="csX6" fmla="*/ 48978 w 364656"/>
-                  <a:gd name="csY6" fmla="*/ 29308 h 333375"/>
-                  <a:gd name="csX7" fmla="*/ 38329 w 364656"/>
-                  <a:gd name="csY7" fmla="*/ 62532 h 333375"/>
-                  <a:gd name="csX8" fmla="*/ 10430 w 364656"/>
-                  <a:gd name="csY8" fmla="*/ 101584 h 333375"/>
-                  <a:gd name="csX9" fmla="*/ 0 w 364656"/>
-                  <a:gd name="csY9" fmla="*/ 129845 h 333375"/>
-                  <a:gd name="csX10" fmla="*/ 20403 w 364656"/>
-                  <a:gd name="csY10" fmla="*/ 333375 h 333375"/>
-                  <a:gd name="csX11" fmla="*/ 96603 w 364656"/>
-                  <a:gd name="csY11" fmla="*/ 333375 h 333375"/>
-                  <a:gd name="csX12" fmla="*/ 268053 w 364656"/>
-                  <a:gd name="csY12" fmla="*/ 333375 h 333375"/>
-                  <a:gd name="csX13" fmla="*/ 344253 w 364656"/>
-                  <a:gd name="csY13" fmla="*/ 333375 h 333375"/>
-                  <a:gd name="csX14" fmla="*/ 364656 w 364656"/>
-                  <a:gd name="csY14" fmla="*/ 129854 h 333375"/>
-                  <a:gd name="csX15" fmla="*/ 182328 w 364656"/>
-                  <a:gd name="csY15" fmla="*/ 242888 h 333375"/>
-                  <a:gd name="csX16" fmla="*/ 129941 w 364656"/>
-                  <a:gd name="csY16" fmla="*/ 190500 h 333375"/>
-                  <a:gd name="csX17" fmla="*/ 182328 w 364656"/>
-                  <a:gd name="csY17" fmla="*/ 138113 h 333375"/>
-                  <a:gd name="csX18" fmla="*/ 234716 w 364656"/>
-                  <a:gd name="csY18" fmla="*/ 190500 h 333375"/>
-                  <a:gd name="csX19" fmla="*/ 182328 w 364656"/>
-                  <a:gd name="csY19" fmla="*/ 242888 h 333375"/>
-                </a:gdLst>
-                <a:ahLst/>
-                <a:cxnLst>
-                  <a:cxn ang="0">
-                    <a:pos x="csX0" y="csY0"/>
-                  </a:cxn>
-                  <a:cxn ang="0">
-                    <a:pos x="csX1" y="csY1"/>
-                  </a:cxn>
-                  <a:cxn ang="0">
-                    <a:pos x="csX2" y="csY2"/>
-                  </a:cxn>
-                  <a:cxn ang="0">
-                    <a:pos x="csX3" y="csY3"/>
-                  </a:cxn>
-                  <a:cxn ang="0">
-                    <a:pos x="csX4" y="csY4"/>
-                  </a:cxn>
-                  <a:cxn ang="0">
-                    <a:pos x="csX5" y="csY5"/>
-                  </a:cxn>
-                  <a:cxn ang="0">
-                    <a:pos x="csX6" y="csY6"/>
-                  </a:cxn>
-                  <a:cxn ang="0">
-                    <a:pos x="csX7" y="csY7"/>
-                  </a:cxn>
-                  <a:cxn ang="0">
-                    <a:pos x="csX8" y="csY8"/>
-                  </a:cxn>
-                  <a:cxn ang="0">
-                    <a:pos x="csX9" y="csY9"/>
-                  </a:cxn>
-                  <a:cxn ang="0">
-                    <a:pos x="csX10" y="csY10"/>
-                  </a:cxn>
-                  <a:cxn ang="0">
-                    <a:pos x="csX11" y="csY11"/>
-                  </a:cxn>
-                  <a:cxn ang="0">
-                    <a:pos x="csX12" y="csY12"/>
-                  </a:cxn>
-                  <a:cxn ang="0">
-                    <a:pos x="csX13" y="csY13"/>
-                  </a:cxn>
-                  <a:cxn ang="0">
-                    <a:pos x="csX14" y="csY14"/>
-                  </a:cxn>
-                  <a:cxn ang="0">
-                    <a:pos x="csX15" y="csY15"/>
-                  </a:cxn>
-                  <a:cxn ang="0">
-                    <a:pos x="csX16" y="csY16"/>
-                  </a:cxn>
-                  <a:cxn ang="0">
-                    <a:pos x="csX17" y="csY17"/>
-                  </a:cxn>
-                  <a:cxn ang="0">
-                    <a:pos x="csX18" y="csY18"/>
-                  </a:cxn>
-                  <a:cxn ang="0">
-                    <a:pos x="csX19" y="csY19"/>
-                  </a:cxn>
-                </a:cxnLst>
-                <a:rect l="l" t="t" r="r" b="b"/>
-                <a:pathLst>
-                  <a:path w="364656" h="333375">
-                    <a:moveTo>
-                      <a:pt x="364656" y="129854"/>
-                    </a:moveTo>
-                    <a:cubicBezTo>
-                      <a:pt x="363769" y="119671"/>
-                      <a:pt x="360167" y="109912"/>
-                      <a:pt x="354226" y="101594"/>
-                    </a:cubicBezTo>
-                    <a:lnTo>
-                      <a:pt x="326327" y="62541"/>
-                    </a:lnTo>
-                    <a:cubicBezTo>
-                      <a:pt x="319401" y="52848"/>
-                      <a:pt x="315678" y="41232"/>
-                      <a:pt x="315678" y="29318"/>
-                    </a:cubicBezTo>
-                    <a:lnTo>
-                      <a:pt x="315678" y="0"/>
-                    </a:lnTo>
-                    <a:lnTo>
-                      <a:pt x="48978" y="0"/>
-                    </a:lnTo>
-                    <a:lnTo>
-                      <a:pt x="48978" y="29308"/>
-                    </a:lnTo>
-                    <a:cubicBezTo>
-                      <a:pt x="48978" y="41222"/>
-                      <a:pt x="45255" y="52838"/>
-                      <a:pt x="38329" y="62532"/>
-                    </a:cubicBezTo>
-                    <a:lnTo>
-                      <a:pt x="10430" y="101584"/>
-                    </a:lnTo>
-                    <a:cubicBezTo>
-                      <a:pt x="4489" y="109902"/>
-                      <a:pt x="887" y="119662"/>
-                      <a:pt x="0" y="129845"/>
-                    </a:cubicBezTo>
-                    <a:lnTo>
-                      <a:pt x="20403" y="333375"/>
-                    </a:lnTo>
-                    <a:lnTo>
-                      <a:pt x="96603" y="333375"/>
-                    </a:lnTo>
-                    <a:lnTo>
-                      <a:pt x="268053" y="333375"/>
-                    </a:lnTo>
-                    <a:lnTo>
-                      <a:pt x="344253" y="333375"/>
-                    </a:lnTo>
-                    <a:lnTo>
-                      <a:pt x="364656" y="129854"/>
-                    </a:lnTo>
-                    <a:close/>
-                    <a:moveTo>
-                      <a:pt x="182328" y="242888"/>
-                    </a:moveTo>
-                    <a:cubicBezTo>
-                      <a:pt x="153395" y="242888"/>
-                      <a:pt x="129941" y="219433"/>
-                      <a:pt x="129941" y="190500"/>
-                    </a:cubicBezTo>
-                    <a:cubicBezTo>
-                      <a:pt x="129941" y="161567"/>
-                      <a:pt x="153395" y="138113"/>
-                      <a:pt x="182328" y="138113"/>
-                    </a:cubicBezTo>
-                    <a:cubicBezTo>
-                      <a:pt x="211261" y="138113"/>
-                      <a:pt x="234716" y="161567"/>
-                      <a:pt x="234716" y="190500"/>
-                    </a:cubicBezTo>
-                    <a:cubicBezTo>
-                      <a:pt x="234684" y="219420"/>
-                      <a:pt x="211248" y="242856"/>
-                      <a:pt x="182328" y="242888"/>
-                    </a:cubicBezTo>
-                    <a:close/>
-                  </a:path>
-                </a:pathLst>
-              </a:custGeom>
-              <a:solidFill>
-                <a:srgbClr val="333333"/>
-              </a:solidFill>
-              <a:ln w="9525" cap="flat">
-                <a:noFill/>
-                <a:prstDash val="solid"/>
-                <a:miter/>
-              </a:ln>
-            </p:spPr>
-            <p:txBody>
-              <a:bodyPr/>
-              <a:lstStyle/>
-              <a:p>
-                <a:endParaRPr lang="fr-CA"/>
-              </a:p>
-            </p:txBody>
-          </p:sp>
-        </p:grpSp>
+            <a:prstGeom prst="ellipse">
+              <a:avLst/>
+            </a:prstGeom>
+            <a:solidFill>
+              <a:srgbClr val="666666"/>
+            </a:solidFill>
+            <a:ln>
+              <a:noFill/>
+            </a:ln>
+          </p:spPr>
+          <p:style>
+            <a:lnRef idx="2">
+              <a:schemeClr val="accent1">
+                <a:shade val="15000"/>
+              </a:schemeClr>
+            </a:lnRef>
+            <a:fillRef idx="1">
+              <a:schemeClr val="accent1"/>
+            </a:fillRef>
+            <a:effectRef idx="0">
+              <a:schemeClr val="accent1"/>
+            </a:effectRef>
+            <a:fontRef idx="minor">
+              <a:schemeClr val="lt1"/>
+            </a:fontRef>
+          </p:style>
+          <p:txBody>
+            <a:bodyPr rtlCol="0" anchor="ctr"/>
+            <a:lstStyle/>
+            <a:p>
+              <a:pPr algn="ctr"/>
+              <a:endParaRPr lang="fr-CA"/>
+            </a:p>
+          </p:txBody>
+        </p:sp>
+        <p:sp>
+          <p:nvSpPr>
+            <p:cNvPr id="49" name="Oval 48">
+              <a:extLst>
+                <a:ext uri="{FF2B5EF4-FFF2-40B4-BE49-F238E27FC236}">
+                  <a16:creationId xmlns:a16="http://schemas.microsoft.com/office/drawing/2014/main" id="{338A52C7-C972-BCD0-0EC7-DA5B49912692}"/>
+                </a:ext>
+              </a:extLst>
+            </p:cNvPr>
+            <p:cNvSpPr/>
+            <p:nvPr/>
+          </p:nvSpPr>
+          <p:spPr>
+            <a:xfrm>
+              <a:off x="9228600" y="1796013"/>
+              <a:ext cx="900000" cy="900000"/>
+            </a:xfrm>
+            <a:prstGeom prst="ellipse">
+              <a:avLst/>
+            </a:prstGeom>
+            <a:solidFill>
+              <a:srgbClr val="666666"/>
+            </a:solidFill>
+            <a:ln>
+              <a:noFill/>
+            </a:ln>
+          </p:spPr>
+          <p:style>
+            <a:lnRef idx="2">
+              <a:schemeClr val="accent1">
+                <a:shade val="15000"/>
+              </a:schemeClr>
+            </a:lnRef>
+            <a:fillRef idx="1">
+              <a:schemeClr val="accent1"/>
+            </a:fillRef>
+            <a:effectRef idx="0">
+              <a:schemeClr val="accent1"/>
+            </a:effectRef>
+            <a:fontRef idx="minor">
+              <a:schemeClr val="lt1"/>
+            </a:fontRef>
+          </p:style>
+          <p:txBody>
+            <a:bodyPr rtlCol="0" anchor="ctr"/>
+            <a:lstStyle/>
+            <a:p>
+              <a:pPr algn="ctr"/>
+              <a:endParaRPr lang="fr-CA"/>
+            </a:p>
+          </p:txBody>
+        </p:sp>
+        <p:sp>
+          <p:nvSpPr>
+            <p:cNvPr id="50" name="Oval 49">
+              <a:extLst>
+                <a:ext uri="{FF2B5EF4-FFF2-40B4-BE49-F238E27FC236}">
+                  <a16:creationId xmlns:a16="http://schemas.microsoft.com/office/drawing/2014/main" id="{3BBD0094-1D77-230E-A932-6FC0356489C2}"/>
+                </a:ext>
+              </a:extLst>
+            </p:cNvPr>
+            <p:cNvSpPr/>
+            <p:nvPr/>
+          </p:nvSpPr>
+          <p:spPr>
+            <a:xfrm>
+              <a:off x="9228600" y="3060000"/>
+              <a:ext cx="900000" cy="900000"/>
+            </a:xfrm>
+            <a:prstGeom prst="ellipse">
+              <a:avLst/>
+            </a:prstGeom>
+            <a:solidFill>
+              <a:srgbClr val="999999"/>
+            </a:solidFill>
+            <a:ln>
+              <a:noFill/>
+            </a:ln>
+          </p:spPr>
+          <p:style>
+            <a:lnRef idx="2">
+              <a:schemeClr val="accent1">
+                <a:shade val="15000"/>
+              </a:schemeClr>
+            </a:lnRef>
+            <a:fillRef idx="1">
+              <a:schemeClr val="accent1"/>
+            </a:fillRef>
+            <a:effectRef idx="0">
+              <a:schemeClr val="accent1"/>
+            </a:effectRef>
+            <a:fontRef idx="minor">
+              <a:schemeClr val="lt1"/>
+            </a:fontRef>
+          </p:style>
+          <p:txBody>
+            <a:bodyPr rtlCol="0" anchor="ctr"/>
+            <a:lstStyle/>
+            <a:p>
+              <a:pPr algn="ctr"/>
+              <a:endParaRPr lang="fr-CA"/>
+            </a:p>
+          </p:txBody>
+        </p:sp>
+        <p:sp>
+          <p:nvSpPr>
+            <p:cNvPr id="51" name="Oval 50">
+              <a:extLst>
+                <a:ext uri="{FF2B5EF4-FFF2-40B4-BE49-F238E27FC236}">
+                  <a16:creationId xmlns:a16="http://schemas.microsoft.com/office/drawing/2014/main" id="{E62086E0-0ADB-7346-147B-2B2E5FB76F24}"/>
+                </a:ext>
+              </a:extLst>
+            </p:cNvPr>
+            <p:cNvSpPr/>
+            <p:nvPr/>
+          </p:nvSpPr>
+          <p:spPr>
+            <a:xfrm>
+              <a:off x="9228600" y="4320000"/>
+              <a:ext cx="900000" cy="900000"/>
+            </a:xfrm>
+            <a:prstGeom prst="ellipse">
+              <a:avLst/>
+            </a:prstGeom>
+            <a:solidFill>
+              <a:srgbClr val="CCCCCC"/>
+            </a:solidFill>
+            <a:ln>
+              <a:noFill/>
+            </a:ln>
+          </p:spPr>
+          <p:style>
+            <a:lnRef idx="2">
+              <a:schemeClr val="accent1">
+                <a:shade val="15000"/>
+              </a:schemeClr>
+            </a:lnRef>
+            <a:fillRef idx="1">
+              <a:schemeClr val="accent1"/>
+            </a:fillRef>
+            <a:effectRef idx="0">
+              <a:schemeClr val="accent1"/>
+            </a:effectRef>
+            <a:fontRef idx="minor">
+              <a:schemeClr val="lt1"/>
+            </a:fontRef>
+          </p:style>
+          <p:txBody>
+            <a:bodyPr rtlCol="0" anchor="ctr"/>
+            <a:lstStyle/>
+            <a:p>
+              <a:pPr algn="ctr"/>
+              <a:endParaRPr lang="fr-CA"/>
+            </a:p>
+          </p:txBody>
+        </p:sp>
       </p:grpSp>
     </p:spTree>
     <p:extLst>

</xml_diff>